<commit_message>
Se agregan las funciones faltantes de listar turnos, consultar agenda medico
</commit_message>
<xml_diff>
--- a/SIGET_Presentacion_40%.pptx
+++ b/SIGET_Presentacion_40%.pptx
@@ -5,20 +5,15 @@
     <p:sldMasterId id="2147483648" r:id="rId1"/>
   </p:sldMasterIdLst>
   <p:notesMasterIdLst>
-    <p:notesMasterId r:id="rId13"/>
+    <p:notesMasterId r:id="rId8"/>
   </p:notesMasterIdLst>
   <p:sldIdLst>
     <p:sldId id="256" r:id="rId2"/>
     <p:sldId id="257" r:id="rId3"/>
     <p:sldId id="258" r:id="rId4"/>
-    <p:sldId id="259" r:id="rId5"/>
-    <p:sldId id="260" r:id="rId6"/>
-    <p:sldId id="261" r:id="rId7"/>
-    <p:sldId id="262" r:id="rId8"/>
-    <p:sldId id="263" r:id="rId9"/>
-    <p:sldId id="264" r:id="rId10"/>
-    <p:sldId id="265" r:id="rId11"/>
-    <p:sldId id="266" r:id="rId12"/>
+    <p:sldId id="260" r:id="rId5"/>
+    <p:sldId id="261" r:id="rId6"/>
+    <p:sldId id="262" r:id="rId7"/>
   </p:sldIdLst>
   <p:sldSz cx="12192000" cy="6858000"/>
   <p:notesSz cx="6858000" cy="12192000"/>
@@ -331,174 +326,6 @@
 </p:notes>
 </file>
 
-<file path=ppt/notesSlides/notesSlide10.xml><?xml version="1.0" encoding="utf-8"?>
-<p:notes xmlns:a="http://schemas.openxmlformats.org/drawingml/2006/main" xmlns:r="http://schemas.openxmlformats.org/officeDocument/2006/relationships" xmlns:p="http://schemas.openxmlformats.org/presentationml/2006/main">
-  <p:cSld>
-    <p:spTree>
-      <p:nvGrpSpPr>
-        <p:cNvPr id="1" name=""/>
-        <p:cNvGrpSpPr/>
-        <p:nvPr/>
-      </p:nvGrpSpPr>
-      <p:grpSpPr>
-        <a:xfrm>
-          <a:off x="0" y="0"/>
-          <a:ext cx="0" cy="0"/>
-          <a:chOff x="0" y="0"/>
-          <a:chExt cx="0" cy="0"/>
-        </a:xfrm>
-      </p:grpSpPr>
-      <p:sp>
-        <p:nvSpPr>
-          <p:cNvPr id="2" name="Slide Image Placeholder 1"/>
-          <p:cNvSpPr>
-            <a:spLocks noGrp="1" noRot="1" noChangeAspect="1"/>
-          </p:cNvSpPr>
-          <p:nvPr>
-            <p:ph type="sldImg"/>
-          </p:nvPr>
-        </p:nvSpPr>
-        <p:spPr/>
-      </p:sp>
-      <p:sp>
-        <p:nvSpPr>
-          <p:cNvPr id="3" name="Notes Placeholder 2"/>
-          <p:cNvSpPr>
-            <a:spLocks noGrp="1"/>
-          </p:cNvSpPr>
-          <p:nvPr>
-            <p:ph type="body" idx="1"/>
-          </p:nvPr>
-        </p:nvSpPr>
-        <p:spPr/>
-        <p:txBody>
-          <a:bodyPr/>
-          <a:lstStyle/>
-          <a:p>
-            <a:endParaRPr lang="en-US" dirty="0"/>
-          </a:p>
-        </p:txBody>
-      </p:sp>
-      <p:sp>
-        <p:nvSpPr>
-          <p:cNvPr id="4" name="Slide Number Placeholder 3"/>
-          <p:cNvSpPr>
-            <a:spLocks noGrp="1"/>
-          </p:cNvSpPr>
-          <p:nvPr>
-            <p:ph type="sldNum" sz="quarter" idx="10"/>
-          </p:nvPr>
-        </p:nvSpPr>
-        <p:spPr/>
-        <p:txBody>
-          <a:bodyPr/>
-          <a:lstStyle/>
-          <a:p>
-            <a:fld id="{F7021451-1387-4CA6-816F-3879F97B5CBC}" type="slidenum">
-              <a:rPr lang="en-US"/>
-              <a:t>10</a:t>
-            </a:fld>
-            <a:endParaRPr lang="en-US"/>
-          </a:p>
-        </p:txBody>
-      </p:sp>
-    </p:spTree>
-    <p:extLst>
-      <p:ext uri="{BB962C8B-B14F-4D97-AF65-F5344CB8AC3E}">
-        <p14:creationId xmlns:p14="http://schemas.microsoft.com/office/powerpoint/2010/main" val="1024086991"/>
-      </p:ext>
-    </p:extLst>
-  </p:cSld>
-  <p:clrMapOvr>
-    <a:masterClrMapping/>
-  </p:clrMapOvr>
-</p:notes>
-</file>
-
-<file path=ppt/notesSlides/notesSlide11.xml><?xml version="1.0" encoding="utf-8"?>
-<p:notes xmlns:a="http://schemas.openxmlformats.org/drawingml/2006/main" xmlns:r="http://schemas.openxmlformats.org/officeDocument/2006/relationships" xmlns:p="http://schemas.openxmlformats.org/presentationml/2006/main">
-  <p:cSld>
-    <p:spTree>
-      <p:nvGrpSpPr>
-        <p:cNvPr id="1" name=""/>
-        <p:cNvGrpSpPr/>
-        <p:nvPr/>
-      </p:nvGrpSpPr>
-      <p:grpSpPr>
-        <a:xfrm>
-          <a:off x="0" y="0"/>
-          <a:ext cx="0" cy="0"/>
-          <a:chOff x="0" y="0"/>
-          <a:chExt cx="0" cy="0"/>
-        </a:xfrm>
-      </p:grpSpPr>
-      <p:sp>
-        <p:nvSpPr>
-          <p:cNvPr id="2" name="Slide Image Placeholder 1"/>
-          <p:cNvSpPr>
-            <a:spLocks noGrp="1" noRot="1" noChangeAspect="1"/>
-          </p:cNvSpPr>
-          <p:nvPr>
-            <p:ph type="sldImg"/>
-          </p:nvPr>
-        </p:nvSpPr>
-        <p:spPr/>
-      </p:sp>
-      <p:sp>
-        <p:nvSpPr>
-          <p:cNvPr id="3" name="Notes Placeholder 2"/>
-          <p:cNvSpPr>
-            <a:spLocks noGrp="1"/>
-          </p:cNvSpPr>
-          <p:nvPr>
-            <p:ph type="body" idx="1"/>
-          </p:nvPr>
-        </p:nvSpPr>
-        <p:spPr/>
-        <p:txBody>
-          <a:bodyPr/>
-          <a:lstStyle/>
-          <a:p>
-            <a:endParaRPr lang="en-US" dirty="0"/>
-          </a:p>
-        </p:txBody>
-      </p:sp>
-      <p:sp>
-        <p:nvSpPr>
-          <p:cNvPr id="4" name="Slide Number Placeholder 3"/>
-          <p:cNvSpPr>
-            <a:spLocks noGrp="1"/>
-          </p:cNvSpPr>
-          <p:nvPr>
-            <p:ph type="sldNum" sz="quarter" idx="10"/>
-          </p:nvPr>
-        </p:nvSpPr>
-        <p:spPr/>
-        <p:txBody>
-          <a:bodyPr/>
-          <a:lstStyle/>
-          <a:p>
-            <a:fld id="{F7021451-1387-4CA6-816F-3879F97B5CBC}" type="slidenum">
-              <a:rPr lang="en-US"/>
-              <a:t>11</a:t>
-            </a:fld>
-            <a:endParaRPr lang="en-US"/>
-          </a:p>
-        </p:txBody>
-      </p:sp>
-    </p:spTree>
-    <p:extLst>
-      <p:ext uri="{BB962C8B-B14F-4D97-AF65-F5344CB8AC3E}">
-        <p14:creationId xmlns:p14="http://schemas.microsoft.com/office/powerpoint/2010/main" val="1024086991"/>
-      </p:ext>
-    </p:extLst>
-  </p:cSld>
-  <p:clrMapOvr>
-    <a:masterClrMapping/>
-  </p:clrMapOvr>
-</p:notes>
-</file>
-
 <file path=ppt/notesSlides/notesSlide2.xml><?xml version="1.0" encoding="utf-8"?>
 <p:notes xmlns:a="http://schemas.openxmlformats.org/drawingml/2006/main" xmlns:r="http://schemas.openxmlformats.org/officeDocument/2006/relationships" xmlns:p="http://schemas.openxmlformats.org/presentationml/2006/main">
   <p:cSld>
@@ -901,258 +728,6 @@
             <a:fld id="{F7021451-1387-4CA6-816F-3879F97B5CBC}" type="slidenum">
               <a:rPr lang="en-US"/>
               <a:t>6</a:t>
-            </a:fld>
-            <a:endParaRPr lang="en-US"/>
-          </a:p>
-        </p:txBody>
-      </p:sp>
-    </p:spTree>
-    <p:extLst>
-      <p:ext uri="{BB962C8B-B14F-4D97-AF65-F5344CB8AC3E}">
-        <p14:creationId xmlns:p14="http://schemas.microsoft.com/office/powerpoint/2010/main" val="1024086991"/>
-      </p:ext>
-    </p:extLst>
-  </p:cSld>
-  <p:clrMapOvr>
-    <a:masterClrMapping/>
-  </p:clrMapOvr>
-</p:notes>
-</file>
-
-<file path=ppt/notesSlides/notesSlide7.xml><?xml version="1.0" encoding="utf-8"?>
-<p:notes xmlns:a="http://schemas.openxmlformats.org/drawingml/2006/main" xmlns:r="http://schemas.openxmlformats.org/officeDocument/2006/relationships" xmlns:p="http://schemas.openxmlformats.org/presentationml/2006/main">
-  <p:cSld>
-    <p:spTree>
-      <p:nvGrpSpPr>
-        <p:cNvPr id="1" name=""/>
-        <p:cNvGrpSpPr/>
-        <p:nvPr/>
-      </p:nvGrpSpPr>
-      <p:grpSpPr>
-        <a:xfrm>
-          <a:off x="0" y="0"/>
-          <a:ext cx="0" cy="0"/>
-          <a:chOff x="0" y="0"/>
-          <a:chExt cx="0" cy="0"/>
-        </a:xfrm>
-      </p:grpSpPr>
-      <p:sp>
-        <p:nvSpPr>
-          <p:cNvPr id="2" name="Slide Image Placeholder 1"/>
-          <p:cNvSpPr>
-            <a:spLocks noGrp="1" noRot="1" noChangeAspect="1"/>
-          </p:cNvSpPr>
-          <p:nvPr>
-            <p:ph type="sldImg"/>
-          </p:nvPr>
-        </p:nvSpPr>
-        <p:spPr/>
-      </p:sp>
-      <p:sp>
-        <p:nvSpPr>
-          <p:cNvPr id="3" name="Notes Placeholder 2"/>
-          <p:cNvSpPr>
-            <a:spLocks noGrp="1"/>
-          </p:cNvSpPr>
-          <p:nvPr>
-            <p:ph type="body" idx="1"/>
-          </p:nvPr>
-        </p:nvSpPr>
-        <p:spPr/>
-        <p:txBody>
-          <a:bodyPr/>
-          <a:lstStyle/>
-          <a:p>
-            <a:endParaRPr lang="en-US" dirty="0"/>
-          </a:p>
-        </p:txBody>
-      </p:sp>
-      <p:sp>
-        <p:nvSpPr>
-          <p:cNvPr id="4" name="Slide Number Placeholder 3"/>
-          <p:cNvSpPr>
-            <a:spLocks noGrp="1"/>
-          </p:cNvSpPr>
-          <p:nvPr>
-            <p:ph type="sldNum" sz="quarter" idx="10"/>
-          </p:nvPr>
-        </p:nvSpPr>
-        <p:spPr/>
-        <p:txBody>
-          <a:bodyPr/>
-          <a:lstStyle/>
-          <a:p>
-            <a:fld id="{F7021451-1387-4CA6-816F-3879F97B5CBC}" type="slidenum">
-              <a:rPr lang="en-US"/>
-              <a:t>7</a:t>
-            </a:fld>
-            <a:endParaRPr lang="en-US"/>
-          </a:p>
-        </p:txBody>
-      </p:sp>
-    </p:spTree>
-    <p:extLst>
-      <p:ext uri="{BB962C8B-B14F-4D97-AF65-F5344CB8AC3E}">
-        <p14:creationId xmlns:p14="http://schemas.microsoft.com/office/powerpoint/2010/main" val="1024086991"/>
-      </p:ext>
-    </p:extLst>
-  </p:cSld>
-  <p:clrMapOvr>
-    <a:masterClrMapping/>
-  </p:clrMapOvr>
-</p:notes>
-</file>
-
-<file path=ppt/notesSlides/notesSlide8.xml><?xml version="1.0" encoding="utf-8"?>
-<p:notes xmlns:a="http://schemas.openxmlformats.org/drawingml/2006/main" xmlns:r="http://schemas.openxmlformats.org/officeDocument/2006/relationships" xmlns:p="http://schemas.openxmlformats.org/presentationml/2006/main">
-  <p:cSld>
-    <p:spTree>
-      <p:nvGrpSpPr>
-        <p:cNvPr id="1" name=""/>
-        <p:cNvGrpSpPr/>
-        <p:nvPr/>
-      </p:nvGrpSpPr>
-      <p:grpSpPr>
-        <a:xfrm>
-          <a:off x="0" y="0"/>
-          <a:ext cx="0" cy="0"/>
-          <a:chOff x="0" y="0"/>
-          <a:chExt cx="0" cy="0"/>
-        </a:xfrm>
-      </p:grpSpPr>
-      <p:sp>
-        <p:nvSpPr>
-          <p:cNvPr id="2" name="Slide Image Placeholder 1"/>
-          <p:cNvSpPr>
-            <a:spLocks noGrp="1" noRot="1" noChangeAspect="1"/>
-          </p:cNvSpPr>
-          <p:nvPr>
-            <p:ph type="sldImg"/>
-          </p:nvPr>
-        </p:nvSpPr>
-        <p:spPr/>
-      </p:sp>
-      <p:sp>
-        <p:nvSpPr>
-          <p:cNvPr id="3" name="Notes Placeholder 2"/>
-          <p:cNvSpPr>
-            <a:spLocks noGrp="1"/>
-          </p:cNvSpPr>
-          <p:nvPr>
-            <p:ph type="body" idx="1"/>
-          </p:nvPr>
-        </p:nvSpPr>
-        <p:spPr/>
-        <p:txBody>
-          <a:bodyPr/>
-          <a:lstStyle/>
-          <a:p>
-            <a:endParaRPr lang="en-US" dirty="0"/>
-          </a:p>
-        </p:txBody>
-      </p:sp>
-      <p:sp>
-        <p:nvSpPr>
-          <p:cNvPr id="4" name="Slide Number Placeholder 3"/>
-          <p:cNvSpPr>
-            <a:spLocks noGrp="1"/>
-          </p:cNvSpPr>
-          <p:nvPr>
-            <p:ph type="sldNum" sz="quarter" idx="10"/>
-          </p:nvPr>
-        </p:nvSpPr>
-        <p:spPr/>
-        <p:txBody>
-          <a:bodyPr/>
-          <a:lstStyle/>
-          <a:p>
-            <a:fld id="{F7021451-1387-4CA6-816F-3879F97B5CBC}" type="slidenum">
-              <a:rPr lang="en-US"/>
-              <a:t>8</a:t>
-            </a:fld>
-            <a:endParaRPr lang="en-US"/>
-          </a:p>
-        </p:txBody>
-      </p:sp>
-    </p:spTree>
-    <p:extLst>
-      <p:ext uri="{BB962C8B-B14F-4D97-AF65-F5344CB8AC3E}">
-        <p14:creationId xmlns:p14="http://schemas.microsoft.com/office/powerpoint/2010/main" val="1024086991"/>
-      </p:ext>
-    </p:extLst>
-  </p:cSld>
-  <p:clrMapOvr>
-    <a:masterClrMapping/>
-  </p:clrMapOvr>
-</p:notes>
-</file>
-
-<file path=ppt/notesSlides/notesSlide9.xml><?xml version="1.0" encoding="utf-8"?>
-<p:notes xmlns:a="http://schemas.openxmlformats.org/drawingml/2006/main" xmlns:r="http://schemas.openxmlformats.org/officeDocument/2006/relationships" xmlns:p="http://schemas.openxmlformats.org/presentationml/2006/main">
-  <p:cSld>
-    <p:spTree>
-      <p:nvGrpSpPr>
-        <p:cNvPr id="1" name=""/>
-        <p:cNvGrpSpPr/>
-        <p:nvPr/>
-      </p:nvGrpSpPr>
-      <p:grpSpPr>
-        <a:xfrm>
-          <a:off x="0" y="0"/>
-          <a:ext cx="0" cy="0"/>
-          <a:chOff x="0" y="0"/>
-          <a:chExt cx="0" cy="0"/>
-        </a:xfrm>
-      </p:grpSpPr>
-      <p:sp>
-        <p:nvSpPr>
-          <p:cNvPr id="2" name="Slide Image Placeholder 1"/>
-          <p:cNvSpPr>
-            <a:spLocks noGrp="1" noRot="1" noChangeAspect="1"/>
-          </p:cNvSpPr>
-          <p:nvPr>
-            <p:ph type="sldImg"/>
-          </p:nvPr>
-        </p:nvSpPr>
-        <p:spPr/>
-      </p:sp>
-      <p:sp>
-        <p:nvSpPr>
-          <p:cNvPr id="3" name="Notes Placeholder 2"/>
-          <p:cNvSpPr>
-            <a:spLocks noGrp="1"/>
-          </p:cNvSpPr>
-          <p:nvPr>
-            <p:ph type="body" idx="1"/>
-          </p:nvPr>
-        </p:nvSpPr>
-        <p:spPr/>
-        <p:txBody>
-          <a:bodyPr/>
-          <a:lstStyle/>
-          <a:p>
-            <a:endParaRPr lang="en-US" dirty="0"/>
-          </a:p>
-        </p:txBody>
-      </p:sp>
-      <p:sp>
-        <p:nvSpPr>
-          <p:cNvPr id="4" name="Slide Number Placeholder 3"/>
-          <p:cNvSpPr>
-            <a:spLocks noGrp="1"/>
-          </p:cNvSpPr>
-          <p:nvPr>
-            <p:ph type="sldNum" sz="quarter" idx="10"/>
-          </p:nvPr>
-        </p:nvSpPr>
-        <p:spPr/>
-        <p:txBody>
-          <a:bodyPr/>
-          <a:lstStyle/>
-          <a:p>
-            <a:fld id="{F7021451-1387-4CA6-816F-3879F97B5CBC}" type="slidenum">
-              <a:rPr lang="en-US"/>
-              <a:t>9</a:t>
             </a:fld>
             <a:endParaRPr lang="en-US"/>
           </a:p>
@@ -1932,1365 +1507,6 @@
 </p:sld>
 </file>
 
-<file path=ppt/slides/slide10.xml><?xml version="1.0" encoding="utf-8"?>
-<p:sld xmlns:a="http://schemas.openxmlformats.org/drawingml/2006/main" xmlns:r="http://schemas.openxmlformats.org/officeDocument/2006/relationships" xmlns:p="http://schemas.openxmlformats.org/presentationml/2006/main">
-  <p:cSld name="Slide 10">
-    <p:bg>
-      <p:bgPr>
-        <a:solidFill>
-          <a:srgbClr val="F4FAF9"/>
-        </a:solidFill>
-        <a:effectLst/>
-      </p:bgPr>
-    </p:bg>
-    <p:spTree>
-      <p:nvGrpSpPr>
-        <p:cNvPr id="1" name=""/>
-        <p:cNvGrpSpPr/>
-        <p:nvPr/>
-      </p:nvGrpSpPr>
-      <p:grpSpPr>
-        <a:xfrm>
-          <a:off x="0" y="0"/>
-          <a:ext cx="0" cy="0"/>
-          <a:chOff x="0" y="0"/>
-          <a:chExt cx="0" cy="0"/>
-        </a:xfrm>
-      </p:grpSpPr>
-      <p:sp>
-        <p:nvSpPr>
-          <p:cNvPr id="2" name="Text 0"/>
-          <p:cNvSpPr txBox="1"/>
-          <p:nvPr/>
-        </p:nvSpPr>
-        <p:spPr>
-          <a:xfrm>
-            <a:off x="548640" y="457200"/>
-            <a:ext cx="10058400" cy="640080"/>
-          </a:xfrm>
-          <a:prstGeom prst="rect">
-            <a:avLst/>
-          </a:prstGeom>
-          <a:noFill/>
-          <a:ln/>
-        </p:spPr>
-        <p:txBody>
-          <a:bodyPr wrap="square" lIns="0" tIns="0" rIns="0" bIns="0" rtlCol="0" anchor="ctr"/>
-          <a:lstStyle/>
-          <a:p>
-            <a:pPr marL="0" indent="0">
-              <a:buNone/>
-            </a:pPr>
-            <a:r>
-              <a:rPr lang="en-US" sz="3000" b="1" dirty="0">
-                <a:solidFill>
-                  <a:srgbClr val="0B2027"/>
-                </a:solidFill>
-                <a:latin typeface="Cambria" pitchFamily="34" charset="0"/>
-                <a:ea typeface="Cambria" pitchFamily="34" charset="-122"/>
-                <a:cs typeface="Cambria" pitchFamily="34" charset="-120"/>
-              </a:rPr>
-              <a:t>Riesgos y cómo los encaramos</a:t>
-            </a:r>
-            <a:endParaRPr lang="en-US" sz="3000" dirty="0"/>
-          </a:p>
-        </p:txBody>
-      </p:sp>
-      <p:sp>
-        <p:nvSpPr>
-          <p:cNvPr id="3" name="Shape 1"/>
-          <p:cNvSpPr/>
-          <p:nvPr/>
-        </p:nvSpPr>
-        <p:spPr>
-          <a:xfrm>
-            <a:off x="548640" y="1417320"/>
-            <a:ext cx="11064240" cy="1051560"/>
-          </a:xfrm>
-          <a:prstGeom prst="roundRect">
-            <a:avLst>
-              <a:gd name="adj" fmla="val 8696"/>
-            </a:avLst>
-          </a:prstGeom>
-          <a:solidFill>
-            <a:srgbClr val="FFFFFF"/>
-          </a:solidFill>
-          <a:ln/>
-          <a:effectLst>
-            <a:outerShdw blurRad="76200" dist="25400" dir="5400000" algn="bl" rotWithShape="0">
-              <a:srgbClr val="0B2027">
-                <a:alpha val="8000"/>
-              </a:srgbClr>
-            </a:outerShdw>
-          </a:effectLst>
-        </p:spPr>
-        <p:txBody>
-          <a:bodyPr/>
-          <a:lstStyle/>
-          <a:p>
-            <a:endParaRPr lang="es-AR"/>
-          </a:p>
-        </p:txBody>
-      </p:sp>
-      <p:sp>
-        <p:nvSpPr>
-          <p:cNvPr id="4" name="Shape 2"/>
-          <p:cNvSpPr/>
-          <p:nvPr/>
-        </p:nvSpPr>
-        <p:spPr>
-          <a:xfrm>
-            <a:off x="937260" y="1600200"/>
-            <a:ext cx="685800" cy="685800"/>
-          </a:xfrm>
-          <a:prstGeom prst="ellipse">
-            <a:avLst/>
-          </a:prstGeom>
-          <a:solidFill>
-            <a:srgbClr val="028090"/>
-          </a:solidFill>
-          <a:ln/>
-        </p:spPr>
-        <p:txBody>
-          <a:bodyPr/>
-          <a:lstStyle/>
-          <a:p>
-            <a:endParaRPr lang="es-AR"/>
-          </a:p>
-        </p:txBody>
-      </p:sp>
-      <p:pic>
-        <p:nvPicPr>
-          <p:cNvPr id="5" name="Image 0" descr="icons/warning.png"/>
-          <p:cNvPicPr>
-            <a:picLocks noChangeAspect="1"/>
-          </p:cNvPicPr>
-          <p:nvPr/>
-        </p:nvPicPr>
-        <p:blipFill>
-          <a:blip r:embed="rId3"/>
-          <a:stretch>
-            <a:fillRect/>
-          </a:stretch>
-        </p:blipFill>
-        <p:spPr>
-          <a:xfrm>
-            <a:off x="1110996" y="1773936"/>
-            <a:ext cx="338328" cy="338328"/>
-          </a:xfrm>
-          <a:prstGeom prst="rect">
-            <a:avLst/>
-          </a:prstGeom>
-        </p:spPr>
-      </p:pic>
-      <p:sp>
-        <p:nvSpPr>
-          <p:cNvPr id="6" name="Text 3"/>
-          <p:cNvSpPr txBox="1"/>
-          <p:nvPr/>
-        </p:nvSpPr>
-        <p:spPr>
-          <a:xfrm>
-            <a:off x="1874520" y="1508760"/>
-            <a:ext cx="4206240" cy="868680"/>
-          </a:xfrm>
-          <a:prstGeom prst="rect">
-            <a:avLst/>
-          </a:prstGeom>
-          <a:noFill/>
-          <a:ln/>
-        </p:spPr>
-        <p:txBody>
-          <a:bodyPr wrap="square" lIns="0" tIns="0" rIns="0" bIns="0" rtlCol="0" anchor="ctr"/>
-          <a:lstStyle/>
-          <a:p>
-            <a:pPr marL="0" indent="0">
-              <a:lnSpc>
-                <a:spcPct val="110000"/>
-              </a:lnSpc>
-              <a:buNone/>
-            </a:pPr>
-            <a:r>
-              <a:rPr lang="en-US" sz="1300" b="1" dirty="0">
-                <a:solidFill>
-                  <a:srgbClr val="0B2027"/>
-                </a:solidFill>
-                <a:latin typeface="Cambria" pitchFamily="34" charset="0"/>
-                <a:ea typeface="Cambria" pitchFamily="34" charset="-122"/>
-                <a:cs typeface="Cambria" pitchFamily="34" charset="-120"/>
-              </a:rPr>
-              <a:t>Validar disponibilidad sin que se pisen los turnos</a:t>
-            </a:r>
-            <a:endParaRPr lang="en-US" sz="1300" dirty="0"/>
-          </a:p>
-        </p:txBody>
-      </p:sp>
-      <p:sp>
-        <p:nvSpPr>
-          <p:cNvPr id="7" name="Shape 4"/>
-          <p:cNvSpPr/>
-          <p:nvPr/>
-        </p:nvSpPr>
-        <p:spPr>
-          <a:xfrm>
-            <a:off x="6263640" y="1554480"/>
-            <a:ext cx="0" cy="777240"/>
-          </a:xfrm>
-          <a:prstGeom prst="line">
-            <a:avLst/>
-          </a:prstGeom>
-          <a:noFill/>
-          <a:ln w="12700">
-            <a:solidFill>
-              <a:srgbClr val="D7E6E4"/>
-            </a:solidFill>
-            <a:prstDash val="solid"/>
-          </a:ln>
-        </p:spPr>
-        <p:txBody>
-          <a:bodyPr/>
-          <a:lstStyle/>
-          <a:p>
-            <a:endParaRPr lang="es-AR"/>
-          </a:p>
-        </p:txBody>
-      </p:sp>
-      <p:sp>
-        <p:nvSpPr>
-          <p:cNvPr id="8" name="Text 5"/>
-          <p:cNvSpPr txBox="1"/>
-          <p:nvPr/>
-        </p:nvSpPr>
-        <p:spPr>
-          <a:xfrm>
-            <a:off x="6492240" y="1508760"/>
-            <a:ext cx="4937760" cy="868680"/>
-          </a:xfrm>
-          <a:prstGeom prst="rect">
-            <a:avLst/>
-          </a:prstGeom>
-          <a:noFill/>
-          <a:ln/>
-        </p:spPr>
-        <p:txBody>
-          <a:bodyPr wrap="square" lIns="0" tIns="0" rIns="0" bIns="0" rtlCol="0" anchor="ctr"/>
-          <a:lstStyle/>
-          <a:p>
-            <a:pPr marL="0" indent="0">
-              <a:lnSpc>
-                <a:spcPct val="110000"/>
-              </a:lnSpc>
-              <a:buNone/>
-            </a:pPr>
-            <a:r>
-              <a:rPr lang="en-US" sz="1250" dirty="0">
-                <a:solidFill>
-                  <a:srgbClr val="4C6B70"/>
-                </a:solidFill>
-                <a:latin typeface="Calibri" pitchFamily="34" charset="0"/>
-                <a:ea typeface="Calibri" pitchFamily="34" charset="-122"/>
-                <a:cs typeface="Calibri" pitchFamily="34" charset="-120"/>
-              </a:rPr>
-              <a:t>Lo encaramos primero, con casos de prueba armados de antemano.</a:t>
-            </a:r>
-            <a:endParaRPr lang="en-US" sz="1250" dirty="0"/>
-          </a:p>
-        </p:txBody>
-      </p:sp>
-      <p:sp>
-        <p:nvSpPr>
-          <p:cNvPr id="9" name="Shape 6"/>
-          <p:cNvSpPr/>
-          <p:nvPr/>
-        </p:nvSpPr>
-        <p:spPr>
-          <a:xfrm>
-            <a:off x="548640" y="2651760"/>
-            <a:ext cx="11064240" cy="1051560"/>
-          </a:xfrm>
-          <a:prstGeom prst="roundRect">
-            <a:avLst>
-              <a:gd name="adj" fmla="val 8696"/>
-            </a:avLst>
-          </a:prstGeom>
-          <a:solidFill>
-            <a:srgbClr val="FFFFFF"/>
-          </a:solidFill>
-          <a:ln/>
-          <a:effectLst>
-            <a:outerShdw blurRad="76200" dist="25400" dir="5400000" algn="bl" rotWithShape="0">
-              <a:srgbClr val="0B2027">
-                <a:alpha val="8000"/>
-              </a:srgbClr>
-            </a:outerShdw>
-          </a:effectLst>
-        </p:spPr>
-        <p:txBody>
-          <a:bodyPr/>
-          <a:lstStyle/>
-          <a:p>
-            <a:endParaRPr lang="es-AR"/>
-          </a:p>
-        </p:txBody>
-      </p:sp>
-      <p:sp>
-        <p:nvSpPr>
-          <p:cNvPr id="10" name="Shape 7"/>
-          <p:cNvSpPr/>
-          <p:nvPr/>
-        </p:nvSpPr>
-        <p:spPr>
-          <a:xfrm>
-            <a:off x="937260" y="2834640"/>
-            <a:ext cx="685800" cy="685800"/>
-          </a:xfrm>
-          <a:prstGeom prst="ellipse">
-            <a:avLst/>
-          </a:prstGeom>
-          <a:solidFill>
-            <a:srgbClr val="028090"/>
-          </a:solidFill>
-          <a:ln/>
-        </p:spPr>
-        <p:txBody>
-          <a:bodyPr/>
-          <a:lstStyle/>
-          <a:p>
-            <a:endParaRPr lang="es-AR"/>
-          </a:p>
-        </p:txBody>
-      </p:sp>
-      <p:pic>
-        <p:nvPicPr>
-          <p:cNvPr id="11" name="Image 1" descr="icons/warning.png"/>
-          <p:cNvPicPr>
-            <a:picLocks noChangeAspect="1"/>
-          </p:cNvPicPr>
-          <p:nvPr/>
-        </p:nvPicPr>
-        <p:blipFill>
-          <a:blip r:embed="rId3"/>
-          <a:stretch>
-            <a:fillRect/>
-          </a:stretch>
-        </p:blipFill>
-        <p:spPr>
-          <a:xfrm>
-            <a:off x="1110996" y="3008376"/>
-            <a:ext cx="338328" cy="338328"/>
-          </a:xfrm>
-          <a:prstGeom prst="rect">
-            <a:avLst/>
-          </a:prstGeom>
-        </p:spPr>
-      </p:pic>
-      <p:sp>
-        <p:nvSpPr>
-          <p:cNvPr id="12" name="Text 8"/>
-          <p:cNvSpPr txBox="1"/>
-          <p:nvPr/>
-        </p:nvSpPr>
-        <p:spPr>
-          <a:xfrm>
-            <a:off x="1874520" y="2743200"/>
-            <a:ext cx="4206240" cy="868680"/>
-          </a:xfrm>
-          <a:prstGeom prst="rect">
-            <a:avLst/>
-          </a:prstGeom>
-          <a:noFill/>
-          <a:ln/>
-        </p:spPr>
-        <p:txBody>
-          <a:bodyPr wrap="square" lIns="0" tIns="0" rIns="0" bIns="0" rtlCol="0" anchor="ctr"/>
-          <a:lstStyle/>
-          <a:p>
-            <a:pPr marL="0" indent="0">
-              <a:lnSpc>
-                <a:spcPct val="110000"/>
-              </a:lnSpc>
-              <a:buNone/>
-            </a:pPr>
-            <a:r>
-              <a:rPr lang="en-US" sz="1300" b="1" dirty="0">
-                <a:solidFill>
-                  <a:srgbClr val="0B2027"/>
-                </a:solidFill>
-                <a:latin typeface="Cambria" pitchFamily="34" charset="0"/>
-                <a:ea typeface="Cambria" pitchFamily="34" charset="-122"/>
-                <a:cs typeface="Cambria" pitchFamily="34" charset="-120"/>
-              </a:rPr>
-              <a:t>Coordinación entre los 4 integrantes</a:t>
-            </a:r>
-            <a:endParaRPr lang="en-US" sz="1300" dirty="0"/>
-          </a:p>
-        </p:txBody>
-      </p:sp>
-      <p:sp>
-        <p:nvSpPr>
-          <p:cNvPr id="13" name="Shape 9"/>
-          <p:cNvSpPr/>
-          <p:nvPr/>
-        </p:nvSpPr>
-        <p:spPr>
-          <a:xfrm>
-            <a:off x="6263640" y="2788920"/>
-            <a:ext cx="0" cy="777240"/>
-          </a:xfrm>
-          <a:prstGeom prst="line">
-            <a:avLst/>
-          </a:prstGeom>
-          <a:noFill/>
-          <a:ln w="12700">
-            <a:solidFill>
-              <a:srgbClr val="D7E6E4"/>
-            </a:solidFill>
-            <a:prstDash val="solid"/>
-          </a:ln>
-        </p:spPr>
-        <p:txBody>
-          <a:bodyPr/>
-          <a:lstStyle/>
-          <a:p>
-            <a:endParaRPr lang="es-AR"/>
-          </a:p>
-        </p:txBody>
-      </p:sp>
-      <p:sp>
-        <p:nvSpPr>
-          <p:cNvPr id="14" name="Text 10"/>
-          <p:cNvSpPr txBox="1"/>
-          <p:nvPr/>
-        </p:nvSpPr>
-        <p:spPr>
-          <a:xfrm>
-            <a:off x="6492240" y="2743200"/>
-            <a:ext cx="4937760" cy="868680"/>
-          </a:xfrm>
-          <a:prstGeom prst="rect">
-            <a:avLst/>
-          </a:prstGeom>
-          <a:noFill/>
-          <a:ln/>
-        </p:spPr>
-        <p:txBody>
-          <a:bodyPr wrap="square" lIns="0" tIns="0" rIns="0" bIns="0" rtlCol="0" anchor="ctr"/>
-          <a:lstStyle/>
-          <a:p>
-            <a:pPr marL="0" indent="0">
-              <a:lnSpc>
-                <a:spcPct val="110000"/>
-              </a:lnSpc>
-              <a:buNone/>
-            </a:pPr>
-            <a:r>
-              <a:rPr lang="en-US" sz="1250" dirty="0">
-                <a:solidFill>
-                  <a:srgbClr val="4C6B70"/>
-                </a:solidFill>
-                <a:latin typeface="Calibri" pitchFamily="34" charset="0"/>
-                <a:ea typeface="Calibri" pitchFamily="34" charset="-122"/>
-                <a:cs typeface="Calibri" pitchFamily="34" charset="-120"/>
-              </a:rPr>
-              <a:t>Módulos independientes, ramas separadas en Git y reunión semanal.</a:t>
-            </a:r>
-            <a:endParaRPr lang="en-US" sz="1250" dirty="0"/>
-          </a:p>
-        </p:txBody>
-      </p:sp>
-      <p:sp>
-        <p:nvSpPr>
-          <p:cNvPr id="15" name="Shape 11"/>
-          <p:cNvSpPr/>
-          <p:nvPr/>
-        </p:nvSpPr>
-        <p:spPr>
-          <a:xfrm>
-            <a:off x="548640" y="3886200"/>
-            <a:ext cx="11064240" cy="1051560"/>
-          </a:xfrm>
-          <a:prstGeom prst="roundRect">
-            <a:avLst>
-              <a:gd name="adj" fmla="val 8696"/>
-            </a:avLst>
-          </a:prstGeom>
-          <a:solidFill>
-            <a:srgbClr val="FFFFFF"/>
-          </a:solidFill>
-          <a:ln/>
-          <a:effectLst>
-            <a:outerShdw blurRad="76200" dist="25400" dir="5400000" algn="bl" rotWithShape="0">
-              <a:srgbClr val="0B2027">
-                <a:alpha val="8000"/>
-              </a:srgbClr>
-            </a:outerShdw>
-          </a:effectLst>
-        </p:spPr>
-        <p:txBody>
-          <a:bodyPr/>
-          <a:lstStyle/>
-          <a:p>
-            <a:endParaRPr lang="es-AR"/>
-          </a:p>
-        </p:txBody>
-      </p:sp>
-      <p:sp>
-        <p:nvSpPr>
-          <p:cNvPr id="16" name="Shape 12"/>
-          <p:cNvSpPr/>
-          <p:nvPr/>
-        </p:nvSpPr>
-        <p:spPr>
-          <a:xfrm>
-            <a:off x="937260" y="4069080"/>
-            <a:ext cx="685800" cy="685800"/>
-          </a:xfrm>
-          <a:prstGeom prst="ellipse">
-            <a:avLst/>
-          </a:prstGeom>
-          <a:solidFill>
-            <a:srgbClr val="028090"/>
-          </a:solidFill>
-          <a:ln/>
-        </p:spPr>
-        <p:txBody>
-          <a:bodyPr/>
-          <a:lstStyle/>
-          <a:p>
-            <a:endParaRPr lang="es-AR"/>
-          </a:p>
-        </p:txBody>
-      </p:sp>
-      <p:pic>
-        <p:nvPicPr>
-          <p:cNvPr id="17" name="Image 2" descr="icons/warning.png"/>
-          <p:cNvPicPr>
-            <a:picLocks noChangeAspect="1"/>
-          </p:cNvPicPr>
-          <p:nvPr/>
-        </p:nvPicPr>
-        <p:blipFill>
-          <a:blip r:embed="rId3"/>
-          <a:stretch>
-            <a:fillRect/>
-          </a:stretch>
-        </p:blipFill>
-        <p:spPr>
-          <a:xfrm>
-            <a:off x="1110996" y="4242816"/>
-            <a:ext cx="338328" cy="338328"/>
-          </a:xfrm>
-          <a:prstGeom prst="rect">
-            <a:avLst/>
-          </a:prstGeom>
-        </p:spPr>
-      </p:pic>
-      <p:sp>
-        <p:nvSpPr>
-          <p:cNvPr id="18" name="Text 13"/>
-          <p:cNvSpPr txBox="1"/>
-          <p:nvPr/>
-        </p:nvSpPr>
-        <p:spPr>
-          <a:xfrm>
-            <a:off x="1874520" y="3977640"/>
-            <a:ext cx="4206240" cy="868680"/>
-          </a:xfrm>
-          <a:prstGeom prst="rect">
-            <a:avLst/>
-          </a:prstGeom>
-          <a:noFill/>
-          <a:ln/>
-        </p:spPr>
-        <p:txBody>
-          <a:bodyPr wrap="square" lIns="0" tIns="0" rIns="0" bIns="0" rtlCol="0" anchor="ctr"/>
-          <a:lstStyle/>
-          <a:p>
-            <a:pPr marL="0" indent="0">
-              <a:lnSpc>
-                <a:spcPct val="110000"/>
-              </a:lnSpc>
-              <a:buNone/>
-            </a:pPr>
-            <a:r>
-              <a:rPr lang="en-US" sz="1300" b="1" dirty="0">
-                <a:solidFill>
-                  <a:srgbClr val="0B2027"/>
-                </a:solidFill>
-                <a:latin typeface="Cambria" pitchFamily="34" charset="0"/>
-                <a:ea typeface="Cambria" pitchFamily="34" charset="-122"/>
-                <a:cs typeface="Cambria" pitchFamily="34" charset="-120"/>
-              </a:rPr>
-              <a:t>Manejo de fechas y horas en Python</a:t>
-            </a:r>
-            <a:endParaRPr lang="en-US" sz="1300" dirty="0"/>
-          </a:p>
-        </p:txBody>
-      </p:sp>
-      <p:sp>
-        <p:nvSpPr>
-          <p:cNvPr id="19" name="Shape 14"/>
-          <p:cNvSpPr/>
-          <p:nvPr/>
-        </p:nvSpPr>
-        <p:spPr>
-          <a:xfrm>
-            <a:off x="6263640" y="4023360"/>
-            <a:ext cx="0" cy="777240"/>
-          </a:xfrm>
-          <a:prstGeom prst="line">
-            <a:avLst/>
-          </a:prstGeom>
-          <a:noFill/>
-          <a:ln w="12700">
-            <a:solidFill>
-              <a:srgbClr val="D7E6E4"/>
-            </a:solidFill>
-            <a:prstDash val="solid"/>
-          </a:ln>
-        </p:spPr>
-        <p:txBody>
-          <a:bodyPr/>
-          <a:lstStyle/>
-          <a:p>
-            <a:endParaRPr lang="es-AR"/>
-          </a:p>
-        </p:txBody>
-      </p:sp>
-      <p:sp>
-        <p:nvSpPr>
-          <p:cNvPr id="20" name="Text 15"/>
-          <p:cNvSpPr txBox="1"/>
-          <p:nvPr/>
-        </p:nvSpPr>
-        <p:spPr>
-          <a:xfrm>
-            <a:off x="6492240" y="3977640"/>
-            <a:ext cx="4937760" cy="868680"/>
-          </a:xfrm>
-          <a:prstGeom prst="rect">
-            <a:avLst/>
-          </a:prstGeom>
-          <a:noFill/>
-          <a:ln/>
-        </p:spPr>
-        <p:txBody>
-          <a:bodyPr wrap="square" lIns="0" tIns="0" rIns="0" bIns="0" rtlCol="0" anchor="ctr"/>
-          <a:lstStyle/>
-          <a:p>
-            <a:pPr marL="0" indent="0">
-              <a:lnSpc>
-                <a:spcPct val="110000"/>
-              </a:lnSpc>
-              <a:buNone/>
-            </a:pPr>
-            <a:r>
-              <a:rPr lang="en-US" sz="1250" dirty="0">
-                <a:solidFill>
-                  <a:srgbClr val="4C6B70"/>
-                </a:solidFill>
-                <a:latin typeface="Calibri" pitchFamily="34" charset="0"/>
-                <a:ea typeface="Calibri" pitchFamily="34" charset="-122"/>
-                <a:cs typeface="Calibri" pitchFamily="34" charset="-120"/>
-              </a:rPr>
-              <a:t>Un único formato definido desde el arranque, validado en funciones reutilizables.</a:t>
-            </a:r>
-            <a:endParaRPr lang="en-US" sz="1250" dirty="0"/>
-          </a:p>
-        </p:txBody>
-      </p:sp>
-      <p:sp>
-        <p:nvSpPr>
-          <p:cNvPr id="21" name="Shape 16"/>
-          <p:cNvSpPr/>
-          <p:nvPr/>
-        </p:nvSpPr>
-        <p:spPr>
-          <a:xfrm>
-            <a:off x="548640" y="5120640"/>
-            <a:ext cx="11064240" cy="1051560"/>
-          </a:xfrm>
-          <a:prstGeom prst="roundRect">
-            <a:avLst>
-              <a:gd name="adj" fmla="val 8696"/>
-            </a:avLst>
-          </a:prstGeom>
-          <a:solidFill>
-            <a:srgbClr val="FFFFFF"/>
-          </a:solidFill>
-          <a:ln/>
-          <a:effectLst>
-            <a:outerShdw blurRad="76200" dist="25400" dir="5400000" algn="bl" rotWithShape="0">
-              <a:srgbClr val="0B2027">
-                <a:alpha val="8000"/>
-              </a:srgbClr>
-            </a:outerShdw>
-          </a:effectLst>
-        </p:spPr>
-        <p:txBody>
-          <a:bodyPr/>
-          <a:lstStyle/>
-          <a:p>
-            <a:endParaRPr lang="es-AR"/>
-          </a:p>
-        </p:txBody>
-      </p:sp>
-      <p:sp>
-        <p:nvSpPr>
-          <p:cNvPr id="22" name="Shape 17"/>
-          <p:cNvSpPr/>
-          <p:nvPr/>
-        </p:nvSpPr>
-        <p:spPr>
-          <a:xfrm>
-            <a:off x="937260" y="5303520"/>
-            <a:ext cx="685800" cy="685800"/>
-          </a:xfrm>
-          <a:prstGeom prst="ellipse">
-            <a:avLst/>
-          </a:prstGeom>
-          <a:solidFill>
-            <a:srgbClr val="028090"/>
-          </a:solidFill>
-          <a:ln/>
-        </p:spPr>
-        <p:txBody>
-          <a:bodyPr/>
-          <a:lstStyle/>
-          <a:p>
-            <a:endParaRPr lang="es-AR"/>
-          </a:p>
-        </p:txBody>
-      </p:sp>
-      <p:pic>
-        <p:nvPicPr>
-          <p:cNvPr id="23" name="Image 3" descr="icons/warning.png"/>
-          <p:cNvPicPr>
-            <a:picLocks noChangeAspect="1"/>
-          </p:cNvPicPr>
-          <p:nvPr/>
-        </p:nvPicPr>
-        <p:blipFill>
-          <a:blip r:embed="rId3"/>
-          <a:stretch>
-            <a:fillRect/>
-          </a:stretch>
-        </p:blipFill>
-        <p:spPr>
-          <a:xfrm>
-            <a:off x="1110996" y="5477256"/>
-            <a:ext cx="338328" cy="338328"/>
-          </a:xfrm>
-          <a:prstGeom prst="rect">
-            <a:avLst/>
-          </a:prstGeom>
-        </p:spPr>
-      </p:pic>
-      <p:sp>
-        <p:nvSpPr>
-          <p:cNvPr id="24" name="Text 18"/>
-          <p:cNvSpPr txBox="1"/>
-          <p:nvPr/>
-        </p:nvSpPr>
-        <p:spPr>
-          <a:xfrm>
-            <a:off x="1874520" y="5212080"/>
-            <a:ext cx="4206240" cy="868680"/>
-          </a:xfrm>
-          <a:prstGeom prst="rect">
-            <a:avLst/>
-          </a:prstGeom>
-          <a:noFill/>
-          <a:ln/>
-        </p:spPr>
-        <p:txBody>
-          <a:bodyPr wrap="square" lIns="0" tIns="0" rIns="0" bIns="0" rtlCol="0" anchor="ctr"/>
-          <a:lstStyle/>
-          <a:p>
-            <a:pPr marL="0" indent="0">
-              <a:lnSpc>
-                <a:spcPct val="110000"/>
-              </a:lnSpc>
-              <a:buNone/>
-            </a:pPr>
-            <a:r>
-              <a:rPr lang="en-US" sz="1300" b="1" dirty="0">
-                <a:solidFill>
-                  <a:srgbClr val="0B2027"/>
-                </a:solidFill>
-                <a:latin typeface="Cambria" pitchFamily="34" charset="0"/>
-                <a:ea typeface="Cambria" pitchFamily="34" charset="-122"/>
-                <a:cs typeface="Cambria" pitchFamily="34" charset="-120"/>
-              </a:rPr>
-              <a:t>Quedarnos cortos de tiempo por otras materias</a:t>
-            </a:r>
-            <a:endParaRPr lang="en-US" sz="1300" dirty="0"/>
-          </a:p>
-        </p:txBody>
-      </p:sp>
-      <p:sp>
-        <p:nvSpPr>
-          <p:cNvPr id="25" name="Shape 19"/>
-          <p:cNvSpPr/>
-          <p:nvPr/>
-        </p:nvSpPr>
-        <p:spPr>
-          <a:xfrm>
-            <a:off x="6263640" y="5257800"/>
-            <a:ext cx="0" cy="777240"/>
-          </a:xfrm>
-          <a:prstGeom prst="line">
-            <a:avLst/>
-          </a:prstGeom>
-          <a:noFill/>
-          <a:ln w="12700">
-            <a:solidFill>
-              <a:srgbClr val="D7E6E4"/>
-            </a:solidFill>
-            <a:prstDash val="solid"/>
-          </a:ln>
-        </p:spPr>
-        <p:txBody>
-          <a:bodyPr/>
-          <a:lstStyle/>
-          <a:p>
-            <a:endParaRPr lang="es-AR"/>
-          </a:p>
-        </p:txBody>
-      </p:sp>
-      <p:sp>
-        <p:nvSpPr>
-          <p:cNvPr id="26" name="Text 20"/>
-          <p:cNvSpPr txBox="1"/>
-          <p:nvPr/>
-        </p:nvSpPr>
-        <p:spPr>
-          <a:xfrm>
-            <a:off x="6492240" y="5212080"/>
-            <a:ext cx="4937760" cy="868680"/>
-          </a:xfrm>
-          <a:prstGeom prst="rect">
-            <a:avLst/>
-          </a:prstGeom>
-          <a:noFill/>
-          <a:ln/>
-        </p:spPr>
-        <p:txBody>
-          <a:bodyPr wrap="square" lIns="0" tIns="0" rIns="0" bIns="0" rtlCol="0" anchor="ctr"/>
-          <a:lstStyle/>
-          <a:p>
-            <a:pPr marL="0" indent="0">
-              <a:lnSpc>
-                <a:spcPct val="110000"/>
-              </a:lnSpc>
-              <a:buNone/>
-            </a:pPr>
-            <a:r>
-              <a:rPr lang="en-US" sz="1250" dirty="0">
-                <a:solidFill>
-                  <a:srgbClr val="4C6B70"/>
-                </a:solidFill>
-                <a:latin typeface="Calibri" pitchFamily="34" charset="0"/>
-                <a:ea typeface="Calibri" pitchFamily="34" charset="-122"/>
-                <a:cs typeface="Calibri" pitchFamily="34" charset="-120"/>
-              </a:rPr>
-              <a:t>Trabajo repartido por módulos que no dependen entre sí.</a:t>
-            </a:r>
-            <a:endParaRPr lang="en-US" sz="1250" dirty="0"/>
-          </a:p>
-        </p:txBody>
-      </p:sp>
-      <p:sp>
-        <p:nvSpPr>
-          <p:cNvPr id="27" name="Text 21"/>
-          <p:cNvSpPr txBox="1"/>
-          <p:nvPr/>
-        </p:nvSpPr>
-        <p:spPr>
-          <a:xfrm>
-            <a:off x="457200" y="6473952"/>
-            <a:ext cx="7315200" cy="274320"/>
-          </a:xfrm>
-          <a:prstGeom prst="rect">
-            <a:avLst/>
-          </a:prstGeom>
-          <a:noFill/>
-          <a:ln/>
-        </p:spPr>
-        <p:txBody>
-          <a:bodyPr wrap="square" lIns="0" tIns="0" rIns="0" bIns="0" rtlCol="0" anchor="ctr"/>
-          <a:lstStyle/>
-          <a:p>
-            <a:pPr marL="0" indent="0">
-              <a:buNone/>
-            </a:pPr>
-            <a:r>
-              <a:rPr lang="en-US" sz="900" dirty="0">
-                <a:solidFill>
-                  <a:srgbClr val="4C6B70"/>
-                </a:solidFill>
-                <a:latin typeface="Calibri" pitchFamily="34" charset="0"/>
-                <a:ea typeface="Calibri" pitchFamily="34" charset="-122"/>
-                <a:cs typeface="Calibri" pitchFamily="34" charset="-120"/>
-              </a:rPr>
-              <a:t>SIGET — Sistema de Gestión de Turnos Médicos</a:t>
-            </a:r>
-            <a:endParaRPr lang="en-US" sz="900" dirty="0"/>
-          </a:p>
-        </p:txBody>
-      </p:sp>
-      <p:sp>
-        <p:nvSpPr>
-          <p:cNvPr id="28" name="Text 22"/>
-          <p:cNvSpPr txBox="1"/>
-          <p:nvPr/>
-        </p:nvSpPr>
-        <p:spPr>
-          <a:xfrm>
-            <a:off x="11274552" y="6473952"/>
-            <a:ext cx="457200" cy="274320"/>
-          </a:xfrm>
-          <a:prstGeom prst="rect">
-            <a:avLst/>
-          </a:prstGeom>
-          <a:noFill/>
-          <a:ln/>
-        </p:spPr>
-        <p:txBody>
-          <a:bodyPr wrap="square" lIns="0" tIns="0" rIns="0" bIns="0" rtlCol="0" anchor="ctr"/>
-          <a:lstStyle/>
-          <a:p>
-            <a:pPr marL="0" indent="0" algn="r">
-              <a:buNone/>
-            </a:pPr>
-            <a:r>
-              <a:rPr lang="en-US" sz="900" dirty="0">
-                <a:solidFill>
-                  <a:srgbClr val="4C6B70"/>
-                </a:solidFill>
-                <a:latin typeface="Calibri" pitchFamily="34" charset="0"/>
-                <a:ea typeface="Calibri" pitchFamily="34" charset="-122"/>
-                <a:cs typeface="Calibri" pitchFamily="34" charset="-120"/>
-              </a:rPr>
-              <a:t>10</a:t>
-            </a:r>
-            <a:endParaRPr lang="en-US" sz="900" dirty="0"/>
-          </a:p>
-        </p:txBody>
-      </p:sp>
-    </p:spTree>
-  </p:cSld>
-  <p:clrMapOvr>
-    <a:masterClrMapping/>
-  </p:clrMapOvr>
-</p:sld>
-</file>
-
-<file path=ppt/slides/slide11.xml><?xml version="1.0" encoding="utf-8"?>
-<p:sld xmlns:a="http://schemas.openxmlformats.org/drawingml/2006/main" xmlns:r="http://schemas.openxmlformats.org/officeDocument/2006/relationships" xmlns:p="http://schemas.openxmlformats.org/presentationml/2006/main">
-  <p:cSld name="Slide 11">
-    <p:bg>
-      <p:bgPr>
-        <a:solidFill>
-          <a:srgbClr val="013A40"/>
-        </a:solidFill>
-        <a:effectLst/>
-      </p:bgPr>
-    </p:bg>
-    <p:spTree>
-      <p:nvGrpSpPr>
-        <p:cNvPr id="1" name=""/>
-        <p:cNvGrpSpPr/>
-        <p:nvPr/>
-      </p:nvGrpSpPr>
-      <p:grpSpPr>
-        <a:xfrm>
-          <a:off x="0" y="0"/>
-          <a:ext cx="0" cy="0"/>
-          <a:chOff x="0" y="0"/>
-          <a:chExt cx="0" cy="0"/>
-        </a:xfrm>
-      </p:grpSpPr>
-      <p:sp>
-        <p:nvSpPr>
-          <p:cNvPr id="2" name="Shape 0"/>
-          <p:cNvSpPr/>
-          <p:nvPr/>
-        </p:nvSpPr>
-        <p:spPr>
-          <a:xfrm>
-            <a:off x="9692640" y="-1828800"/>
-            <a:ext cx="5486400" cy="5486400"/>
-          </a:xfrm>
-          <a:prstGeom prst="ellipse">
-            <a:avLst/>
-          </a:prstGeom>
-          <a:solidFill>
-            <a:srgbClr val="028090">
-              <a:alpha val="45000"/>
-            </a:srgbClr>
-          </a:solidFill>
-          <a:ln/>
-        </p:spPr>
-        <p:txBody>
-          <a:bodyPr/>
-          <a:lstStyle/>
-          <a:p>
-            <a:endParaRPr lang="es-AR"/>
-          </a:p>
-        </p:txBody>
-      </p:sp>
-      <p:sp>
-        <p:nvSpPr>
-          <p:cNvPr id="3" name="Shape 1"/>
-          <p:cNvSpPr/>
-          <p:nvPr/>
-        </p:nvSpPr>
-        <p:spPr>
-          <a:xfrm>
-            <a:off x="1005840" y="685800"/>
-            <a:ext cx="1188720" cy="1188720"/>
-          </a:xfrm>
-          <a:prstGeom prst="ellipse">
-            <a:avLst/>
-          </a:prstGeom>
-          <a:solidFill>
-            <a:srgbClr val="02C39A"/>
-          </a:solidFill>
-          <a:ln/>
-        </p:spPr>
-        <p:txBody>
-          <a:bodyPr/>
-          <a:lstStyle/>
-          <a:p>
-            <a:endParaRPr lang="es-AR"/>
-          </a:p>
-        </p:txBody>
-      </p:sp>
-      <p:pic>
-        <p:nvPicPr>
-          <p:cNvPr id="4" name="Image 0" descr="icons/users.png"/>
-          <p:cNvPicPr>
-            <a:picLocks noChangeAspect="1"/>
-          </p:cNvPicPr>
-          <p:nvPr/>
-        </p:nvPicPr>
-        <p:blipFill>
-          <a:blip r:embed="rId3"/>
-          <a:stretch>
-            <a:fillRect/>
-          </a:stretch>
-        </p:blipFill>
-        <p:spPr>
-          <a:xfrm>
-            <a:off x="1280160" y="960120"/>
-            <a:ext cx="640080" cy="640080"/>
-          </a:xfrm>
-          <a:prstGeom prst="rect">
-            <a:avLst/>
-          </a:prstGeom>
-        </p:spPr>
-      </p:pic>
-      <p:sp>
-        <p:nvSpPr>
-          <p:cNvPr id="5" name="Text 2"/>
-          <p:cNvSpPr txBox="1"/>
-          <p:nvPr/>
-        </p:nvSpPr>
-        <p:spPr>
-          <a:xfrm>
-            <a:off x="822960" y="2057400"/>
-            <a:ext cx="7315200" cy="640080"/>
-          </a:xfrm>
-          <a:prstGeom prst="rect">
-            <a:avLst/>
-          </a:prstGeom>
-          <a:noFill/>
-          <a:ln/>
-        </p:spPr>
-        <p:txBody>
-          <a:bodyPr wrap="square" lIns="0" tIns="0" rIns="0" bIns="0" rtlCol="0" anchor="ctr"/>
-          <a:lstStyle/>
-          <a:p>
-            <a:pPr marL="0" indent="0">
-              <a:buNone/>
-            </a:pPr>
-            <a:r>
-              <a:rPr lang="en-US" sz="3000" b="1" dirty="0">
-                <a:solidFill>
-                  <a:srgbClr val="FFFFFF"/>
-                </a:solidFill>
-                <a:latin typeface="Cambria" pitchFamily="34" charset="0"/>
-                <a:ea typeface="Cambria" pitchFamily="34" charset="-122"/>
-                <a:cs typeface="Cambria" pitchFamily="34" charset="-120"/>
-              </a:rPr>
-              <a:t>Grupo 8</a:t>
-            </a:r>
-            <a:endParaRPr lang="en-US" sz="3000" dirty="0"/>
-          </a:p>
-        </p:txBody>
-      </p:sp>
-      <p:sp>
-        <p:nvSpPr>
-          <p:cNvPr id="6" name="Text 3"/>
-          <p:cNvSpPr txBox="1"/>
-          <p:nvPr/>
-        </p:nvSpPr>
-        <p:spPr>
-          <a:xfrm>
-            <a:off x="868680" y="2834640"/>
-            <a:ext cx="7772400" cy="2011680"/>
-          </a:xfrm>
-          <a:prstGeom prst="rect">
-            <a:avLst/>
-          </a:prstGeom>
-          <a:noFill/>
-          <a:ln/>
-        </p:spPr>
-        <p:txBody>
-          <a:bodyPr wrap="square" lIns="0" tIns="0" rIns="0" bIns="0" rtlCol="0" anchor="ctr"/>
-          <a:lstStyle/>
-          <a:p>
-            <a:pPr marL="342900" indent="-342900">
-              <a:spcAft>
-                <a:spcPts val="1000"/>
-              </a:spcAft>
-              <a:buSzPct val="100000"/>
-              <a:buChar char="•"/>
-            </a:pPr>
-            <a:r>
-              <a:rPr lang="en-US" sz="1400" dirty="0">
-                <a:solidFill>
-                  <a:srgbClr val="D7ECEA"/>
-                </a:solidFill>
-                <a:latin typeface="Calibri" pitchFamily="34" charset="0"/>
-                <a:ea typeface="Calibri" pitchFamily="34" charset="-122"/>
-                <a:cs typeface="Calibri" pitchFamily="34" charset="-120"/>
-              </a:rPr>
-              <a:t>Teo Mazzoni — Login y estructura base</a:t>
-            </a:r>
-            <a:endParaRPr lang="en-US" sz="1400" dirty="0"/>
-          </a:p>
-          <a:p>
-            <a:pPr marL="342900" indent="-342900">
-              <a:spcAft>
-                <a:spcPts val="1000"/>
-              </a:spcAft>
-              <a:buSzPct val="100000"/>
-              <a:buChar char="•"/>
-            </a:pPr>
-            <a:r>
-              <a:rPr lang="en-US" sz="1400" dirty="0">
-                <a:solidFill>
-                  <a:srgbClr val="D7ECEA"/>
-                </a:solidFill>
-                <a:latin typeface="Calibri" pitchFamily="34" charset="0"/>
-                <a:ea typeface="Calibri" pitchFamily="34" charset="-122"/>
-                <a:cs typeface="Calibri" pitchFamily="34" charset="-120"/>
-              </a:rPr>
-              <a:t>Priscilla Melva Giron Arenas — ABMs del administrador</a:t>
-            </a:r>
-            <a:endParaRPr lang="en-US" sz="1400" dirty="0"/>
-          </a:p>
-          <a:p>
-            <a:pPr marL="342900" indent="-342900">
-              <a:spcAft>
-                <a:spcPts val="1000"/>
-              </a:spcAft>
-              <a:buSzPct val="100000"/>
-              <a:buChar char="•"/>
-            </a:pPr>
-            <a:r>
-              <a:rPr lang="en-US" sz="1400" dirty="0">
-                <a:solidFill>
-                  <a:srgbClr val="D7ECEA"/>
-                </a:solidFill>
-                <a:latin typeface="Calibri" pitchFamily="34" charset="0"/>
-                <a:ea typeface="Calibri" pitchFamily="34" charset="-122"/>
-                <a:cs typeface="Calibri" pitchFamily="34" charset="-120"/>
-              </a:rPr>
-              <a:t>Marcelo Nieli — Login/ABMs admin y agenda</a:t>
-            </a:r>
-            <a:endParaRPr lang="en-US" sz="1400" dirty="0"/>
-          </a:p>
-          <a:p>
-            <a:pPr marL="342900" indent="-342900">
-              <a:spcAft>
-                <a:spcPts val="1000"/>
-              </a:spcAft>
-              <a:buSzPct val="100000"/>
-              <a:buChar char="•"/>
-            </a:pPr>
-            <a:r>
-              <a:rPr lang="en-US" sz="1400" dirty="0">
-                <a:solidFill>
-                  <a:srgbClr val="D7ECEA"/>
-                </a:solidFill>
-                <a:latin typeface="Calibri" pitchFamily="34" charset="0"/>
-                <a:ea typeface="Calibri" pitchFamily="34" charset="-122"/>
-                <a:cs typeface="Calibri" pitchFamily="34" charset="-120"/>
-              </a:rPr>
-              <a:t>Cayetano Masi — Pacientes y asignación de turnos</a:t>
-            </a:r>
-            <a:endParaRPr lang="en-US" sz="1400" dirty="0"/>
-          </a:p>
-        </p:txBody>
-      </p:sp>
-      <p:sp>
-        <p:nvSpPr>
-          <p:cNvPr id="7" name="Shape 4"/>
-          <p:cNvSpPr/>
-          <p:nvPr/>
-        </p:nvSpPr>
-        <p:spPr>
-          <a:xfrm>
-            <a:off x="868680" y="5120640"/>
-            <a:ext cx="3840480" cy="0"/>
-          </a:xfrm>
-          <a:prstGeom prst="line">
-            <a:avLst/>
-          </a:prstGeom>
-          <a:noFill/>
-          <a:ln w="12700">
-            <a:solidFill>
-              <a:srgbClr val="2E6A70"/>
-            </a:solidFill>
-            <a:prstDash val="solid"/>
-          </a:ln>
-        </p:spPr>
-        <p:txBody>
-          <a:bodyPr/>
-          <a:lstStyle/>
-          <a:p>
-            <a:endParaRPr lang="es-AR"/>
-          </a:p>
-        </p:txBody>
-      </p:sp>
-      <p:sp>
-        <p:nvSpPr>
-          <p:cNvPr id="8" name="Text 5"/>
-          <p:cNvSpPr txBox="1"/>
-          <p:nvPr/>
-        </p:nvSpPr>
-        <p:spPr>
-          <a:xfrm>
-            <a:off x="868680" y="5303520"/>
-            <a:ext cx="9144000" cy="365760"/>
-          </a:xfrm>
-          <a:prstGeom prst="rect">
-            <a:avLst/>
-          </a:prstGeom>
-          <a:noFill/>
-          <a:ln/>
-        </p:spPr>
-        <p:txBody>
-          <a:bodyPr wrap="square" lIns="0" tIns="0" rIns="0" bIns="0" rtlCol="0" anchor="ctr"/>
-          <a:lstStyle/>
-          <a:p>
-            <a:pPr marL="0" indent="0">
-              <a:buNone/>
-            </a:pPr>
-            <a:r>
-              <a:rPr lang="en-US" sz="1200" dirty="0">
-                <a:solidFill>
-                  <a:srgbClr val="BFDDD9"/>
-                </a:solidFill>
-                <a:latin typeface="Calibri" pitchFamily="34" charset="0"/>
-                <a:ea typeface="Calibri" pitchFamily="34" charset="-122"/>
-                <a:cs typeface="Calibri" pitchFamily="34" charset="-120"/>
-              </a:rPr>
-              <a:t>Materia: Programación 1 (3.4.071)  ·  Docente: María Julia Monasterio</a:t>
-            </a:r>
-            <a:endParaRPr lang="en-US" sz="1200" dirty="0"/>
-          </a:p>
-        </p:txBody>
-      </p:sp>
-      <p:sp>
-        <p:nvSpPr>
-          <p:cNvPr id="9" name="Text 6"/>
-          <p:cNvSpPr txBox="1"/>
-          <p:nvPr/>
-        </p:nvSpPr>
-        <p:spPr>
-          <a:xfrm>
-            <a:off x="457200" y="6473952"/>
-            <a:ext cx="7315200" cy="274320"/>
-          </a:xfrm>
-          <a:prstGeom prst="rect">
-            <a:avLst/>
-          </a:prstGeom>
-          <a:noFill/>
-          <a:ln/>
-        </p:spPr>
-        <p:txBody>
-          <a:bodyPr wrap="square" lIns="0" tIns="0" rIns="0" bIns="0" rtlCol="0" anchor="ctr"/>
-          <a:lstStyle/>
-          <a:p>
-            <a:pPr marL="0" indent="0">
-              <a:buNone/>
-            </a:pPr>
-            <a:r>
-              <a:rPr lang="en-US" sz="900" dirty="0">
-                <a:solidFill>
-                  <a:srgbClr val="BFDDD9"/>
-                </a:solidFill>
-                <a:latin typeface="Calibri" pitchFamily="34" charset="0"/>
-                <a:ea typeface="Calibri" pitchFamily="34" charset="-122"/>
-                <a:cs typeface="Calibri" pitchFamily="34" charset="-120"/>
-              </a:rPr>
-              <a:t>SIGET — Sistema de Gestión de Turnos Médicos</a:t>
-            </a:r>
-            <a:endParaRPr lang="en-US" sz="900" dirty="0"/>
-          </a:p>
-        </p:txBody>
-      </p:sp>
-      <p:sp>
-        <p:nvSpPr>
-          <p:cNvPr id="10" name="Text 7"/>
-          <p:cNvSpPr txBox="1"/>
-          <p:nvPr/>
-        </p:nvSpPr>
-        <p:spPr>
-          <a:xfrm>
-            <a:off x="11274552" y="6473952"/>
-            <a:ext cx="457200" cy="274320"/>
-          </a:xfrm>
-          <a:prstGeom prst="rect">
-            <a:avLst/>
-          </a:prstGeom>
-          <a:noFill/>
-          <a:ln/>
-        </p:spPr>
-        <p:txBody>
-          <a:bodyPr wrap="square" lIns="0" tIns="0" rIns="0" bIns="0" rtlCol="0" anchor="ctr"/>
-          <a:lstStyle/>
-          <a:p>
-            <a:pPr marL="0" indent="0" algn="r">
-              <a:buNone/>
-            </a:pPr>
-            <a:r>
-              <a:rPr lang="en-US" sz="900" dirty="0">
-                <a:solidFill>
-                  <a:srgbClr val="BFDDD9"/>
-                </a:solidFill>
-                <a:latin typeface="Calibri" pitchFamily="34" charset="0"/>
-                <a:ea typeface="Calibri" pitchFamily="34" charset="-122"/>
-                <a:cs typeface="Calibri" pitchFamily="34" charset="-120"/>
-              </a:rPr>
-              <a:t>11</a:t>
-            </a:r>
-            <a:endParaRPr lang="en-US" sz="900" dirty="0"/>
-          </a:p>
-        </p:txBody>
-      </p:sp>
-    </p:spTree>
-  </p:cSld>
-  <p:clrMapOvr>
-    <a:masterClrMapping/>
-  </p:clrMapOvr>
-</p:sld>
-</file>
-
 <file path=ppt/slides/slide2.xml><?xml version="1.0" encoding="utf-8"?>
 <p:sld xmlns:a="http://schemas.openxmlformats.org/drawingml/2006/main" xmlns:r="http://schemas.openxmlformats.org/officeDocument/2006/relationships" xmlns:p="http://schemas.openxmlformats.org/presentationml/2006/main">
   <p:cSld name="Slide 2">
@@ -3671,8 +1887,8 @@
         </p:blipFill>
         <p:spPr>
           <a:xfrm>
-            <a:off x="5673852" y="2747772"/>
-            <a:ext cx="539496" cy="539496"/>
+            <a:off x="5744797" y="2747772"/>
+            <a:ext cx="422148" cy="422148"/>
           </a:xfrm>
           <a:prstGeom prst="rect">
             <a:avLst/>
@@ -4481,278 +2697,6 @@
 
 <file path=ppt/slides/slide4.xml><?xml version="1.0" encoding="utf-8"?>
 <p:sld xmlns:a="http://schemas.openxmlformats.org/drawingml/2006/main" xmlns:r="http://schemas.openxmlformats.org/officeDocument/2006/relationships" xmlns:p="http://schemas.openxmlformats.org/presentationml/2006/main">
-  <p:cSld name="Slide 4">
-    <p:bg>
-      <p:bgPr>
-        <a:solidFill>
-          <a:srgbClr val="013A40"/>
-        </a:solidFill>
-        <a:effectLst/>
-      </p:bgPr>
-    </p:bg>
-    <p:spTree>
-      <p:nvGrpSpPr>
-        <p:cNvPr id="1" name=""/>
-        <p:cNvGrpSpPr/>
-        <p:nvPr/>
-      </p:nvGrpSpPr>
-      <p:grpSpPr>
-        <a:xfrm>
-          <a:off x="0" y="0"/>
-          <a:ext cx="0" cy="0"/>
-          <a:chOff x="0" y="0"/>
-          <a:chExt cx="0" cy="0"/>
-        </a:xfrm>
-      </p:grpSpPr>
-      <p:sp>
-        <p:nvSpPr>
-          <p:cNvPr id="2" name="Shape 0"/>
-          <p:cNvSpPr/>
-          <p:nvPr/>
-        </p:nvSpPr>
-        <p:spPr>
-          <a:xfrm>
-            <a:off x="-1828800" y="-2011680"/>
-            <a:ext cx="5486400" cy="5486400"/>
-          </a:xfrm>
-          <a:prstGeom prst="ellipse">
-            <a:avLst/>
-          </a:prstGeom>
-          <a:solidFill>
-            <a:srgbClr val="028090">
-              <a:alpha val="45000"/>
-            </a:srgbClr>
-          </a:solidFill>
-          <a:ln/>
-        </p:spPr>
-        <p:txBody>
-          <a:bodyPr/>
-          <a:lstStyle/>
-          <a:p>
-            <a:endParaRPr lang="es-AR"/>
-          </a:p>
-        </p:txBody>
-      </p:sp>
-      <p:sp>
-        <p:nvSpPr>
-          <p:cNvPr id="3" name="Shape 1"/>
-          <p:cNvSpPr/>
-          <p:nvPr/>
-        </p:nvSpPr>
-        <p:spPr>
-          <a:xfrm>
-            <a:off x="5408676" y="1051560"/>
-            <a:ext cx="1371600" cy="1371600"/>
-          </a:xfrm>
-          <a:prstGeom prst="ellipse">
-            <a:avLst/>
-          </a:prstGeom>
-          <a:solidFill>
-            <a:srgbClr val="02C39A"/>
-          </a:solidFill>
-          <a:ln/>
-        </p:spPr>
-        <p:txBody>
-          <a:bodyPr/>
-          <a:lstStyle/>
-          <a:p>
-            <a:endParaRPr lang="es-AR"/>
-          </a:p>
-        </p:txBody>
-      </p:sp>
-      <p:pic>
-        <p:nvPicPr>
-          <p:cNvPr id="4" name="Image 0" descr="icons/bullseye.png"/>
-          <p:cNvPicPr>
-            <a:picLocks noChangeAspect="1"/>
-          </p:cNvPicPr>
-          <p:nvPr/>
-        </p:nvPicPr>
-        <p:blipFill>
-          <a:blip r:embed="rId3"/>
-          <a:stretch>
-            <a:fillRect/>
-          </a:stretch>
-        </p:blipFill>
-        <p:spPr>
-          <a:xfrm>
-            <a:off x="5719572" y="1362456"/>
-            <a:ext cx="749808" cy="749808"/>
-          </a:xfrm>
-          <a:prstGeom prst="rect">
-            <a:avLst/>
-          </a:prstGeom>
-        </p:spPr>
-      </p:pic>
-      <p:sp>
-        <p:nvSpPr>
-          <p:cNvPr id="5" name="Text 2"/>
-          <p:cNvSpPr txBox="1"/>
-          <p:nvPr/>
-        </p:nvSpPr>
-        <p:spPr>
-          <a:xfrm>
-            <a:off x="914400" y="2743200"/>
-            <a:ext cx="10332720" cy="548640"/>
-          </a:xfrm>
-          <a:prstGeom prst="rect">
-            <a:avLst/>
-          </a:prstGeom>
-          <a:noFill/>
-          <a:ln/>
-        </p:spPr>
-        <p:txBody>
-          <a:bodyPr wrap="square" lIns="0" tIns="0" rIns="0" bIns="0" rtlCol="0" anchor="ctr"/>
-          <a:lstStyle/>
-          <a:p>
-            <a:pPr marL="0" indent="0" algn="ctr">
-              <a:buNone/>
-            </a:pPr>
-            <a:r>
-              <a:rPr lang="en-US" sz="2400" b="1" dirty="0">
-                <a:solidFill>
-                  <a:srgbClr val="02C39A"/>
-                </a:solidFill>
-                <a:latin typeface="Cambria" pitchFamily="34" charset="0"/>
-                <a:ea typeface="Cambria" pitchFamily="34" charset="-122"/>
-                <a:cs typeface="Cambria" pitchFamily="34" charset="-120"/>
-              </a:rPr>
-              <a:t>Objetivo general</a:t>
-            </a:r>
-            <a:endParaRPr lang="en-US" sz="2400" dirty="0"/>
-          </a:p>
-        </p:txBody>
-      </p:sp>
-      <p:sp>
-        <p:nvSpPr>
-          <p:cNvPr id="6" name="Text 3"/>
-          <p:cNvSpPr txBox="1"/>
-          <p:nvPr/>
-        </p:nvSpPr>
-        <p:spPr>
-          <a:xfrm>
-            <a:off x="1737360" y="3383280"/>
-            <a:ext cx="8686800" cy="2011680"/>
-          </a:xfrm>
-          <a:prstGeom prst="rect">
-            <a:avLst/>
-          </a:prstGeom>
-          <a:noFill/>
-          <a:ln/>
-        </p:spPr>
-        <p:txBody>
-          <a:bodyPr wrap="square" lIns="0" tIns="0" rIns="0" bIns="0" rtlCol="0" anchor="ctr"/>
-          <a:lstStyle/>
-          <a:p>
-            <a:pPr marL="0" indent="0" algn="ctr">
-              <a:lnSpc>
-                <a:spcPct val="130000"/>
-              </a:lnSpc>
-              <a:buNone/>
-            </a:pPr>
-            <a:r>
-              <a:rPr lang="en-US" sz="1800" dirty="0">
-                <a:solidFill>
-                  <a:srgbClr val="FFFFFF"/>
-                </a:solidFill>
-                <a:latin typeface="Calibri" pitchFamily="34" charset="0"/>
-                <a:ea typeface="Calibri" pitchFamily="34" charset="-122"/>
-                <a:cs typeface="Calibri" pitchFamily="34" charset="-120"/>
-              </a:rPr>
-              <a:t>Desarrollar en Python una aplicación de consola para administrar los turnos de un centro médico, con acceso separado por rol, control de disponibilidad de cada médico, registro de la atención y reportes de uso diario.</a:t>
-            </a:r>
-            <a:endParaRPr lang="en-US" sz="1800" dirty="0"/>
-          </a:p>
-        </p:txBody>
-      </p:sp>
-      <p:sp>
-        <p:nvSpPr>
-          <p:cNvPr id="7" name="Text 4"/>
-          <p:cNvSpPr txBox="1"/>
-          <p:nvPr/>
-        </p:nvSpPr>
-        <p:spPr>
-          <a:xfrm>
-            <a:off x="457200" y="6473952"/>
-            <a:ext cx="7315200" cy="274320"/>
-          </a:xfrm>
-          <a:prstGeom prst="rect">
-            <a:avLst/>
-          </a:prstGeom>
-          <a:noFill/>
-          <a:ln/>
-        </p:spPr>
-        <p:txBody>
-          <a:bodyPr wrap="square" lIns="0" tIns="0" rIns="0" bIns="0" rtlCol="0" anchor="ctr"/>
-          <a:lstStyle/>
-          <a:p>
-            <a:pPr marL="0" indent="0">
-              <a:buNone/>
-            </a:pPr>
-            <a:r>
-              <a:rPr lang="en-US" sz="900" dirty="0">
-                <a:solidFill>
-                  <a:srgbClr val="BFDDD9"/>
-                </a:solidFill>
-                <a:latin typeface="Calibri" pitchFamily="34" charset="0"/>
-                <a:ea typeface="Calibri" pitchFamily="34" charset="-122"/>
-                <a:cs typeface="Calibri" pitchFamily="34" charset="-120"/>
-              </a:rPr>
-              <a:t>SIGET — Sistema de Gestión de Turnos Médicos</a:t>
-            </a:r>
-            <a:endParaRPr lang="en-US" sz="900" dirty="0"/>
-          </a:p>
-        </p:txBody>
-      </p:sp>
-      <p:sp>
-        <p:nvSpPr>
-          <p:cNvPr id="8" name="Text 5"/>
-          <p:cNvSpPr txBox="1"/>
-          <p:nvPr/>
-        </p:nvSpPr>
-        <p:spPr>
-          <a:xfrm>
-            <a:off x="11274552" y="6473952"/>
-            <a:ext cx="457200" cy="274320"/>
-          </a:xfrm>
-          <a:prstGeom prst="rect">
-            <a:avLst/>
-          </a:prstGeom>
-          <a:noFill/>
-          <a:ln/>
-        </p:spPr>
-        <p:txBody>
-          <a:bodyPr wrap="square" lIns="0" tIns="0" rIns="0" bIns="0" rtlCol="0" anchor="ctr"/>
-          <a:lstStyle/>
-          <a:p>
-            <a:pPr marL="0" indent="0" algn="r">
-              <a:buNone/>
-            </a:pPr>
-            <a:r>
-              <a:rPr lang="en-US" sz="900" dirty="0">
-                <a:solidFill>
-                  <a:srgbClr val="BFDDD9"/>
-                </a:solidFill>
-                <a:latin typeface="Calibri" pitchFamily="34" charset="0"/>
-                <a:ea typeface="Calibri" pitchFamily="34" charset="-122"/>
-                <a:cs typeface="Calibri" pitchFamily="34" charset="-120"/>
-              </a:rPr>
-              <a:t>4</a:t>
-            </a:r>
-            <a:endParaRPr lang="en-US" sz="900" dirty="0"/>
-          </a:p>
-        </p:txBody>
-      </p:sp>
-    </p:spTree>
-  </p:cSld>
-  <p:clrMapOvr>
-    <a:masterClrMapping/>
-  </p:clrMapOvr>
-</p:sld>
-</file>
-
-<file path=ppt/slides/slide5.xml><?xml version="1.0" encoding="utf-8"?>
-<p:sld xmlns:a="http://schemas.openxmlformats.org/drawingml/2006/main" xmlns:r="http://schemas.openxmlformats.org/officeDocument/2006/relationships" xmlns:p="http://schemas.openxmlformats.org/presentationml/2006/main">
   <p:cSld name="Slide 5">
     <p:bg>
       <p:bgPr>
@@ -5477,138 +3421,6 @@
       </p:sp>
       <p:sp>
         <p:nvSpPr>
-          <p:cNvPr id="23" name="Shape 16"/>
-          <p:cNvSpPr/>
-          <p:nvPr/>
-        </p:nvSpPr>
-        <p:spPr>
-          <a:xfrm>
-            <a:off x="8023860" y="3909060"/>
-            <a:ext cx="960120" cy="960120"/>
-          </a:xfrm>
-          <a:prstGeom prst="ellipse">
-            <a:avLst/>
-          </a:prstGeom>
-          <a:solidFill>
-            <a:srgbClr val="00A896"/>
-          </a:solidFill>
-          <a:ln/>
-        </p:spPr>
-        <p:txBody>
-          <a:bodyPr/>
-          <a:lstStyle/>
-          <a:p>
-            <a:endParaRPr lang="es-AR"/>
-          </a:p>
-        </p:txBody>
-      </p:sp>
-      <p:pic>
-        <p:nvPicPr>
-          <p:cNvPr id="24" name="Image 5" descr="icons/save.png"/>
-          <p:cNvPicPr>
-            <a:picLocks noChangeAspect="1"/>
-          </p:cNvPicPr>
-          <p:nvPr/>
-        </p:nvPicPr>
-        <p:blipFill>
-          <a:blip r:embed="rId8"/>
-          <a:stretch>
-            <a:fillRect/>
-          </a:stretch>
-        </p:blipFill>
-        <p:spPr>
-          <a:xfrm>
-            <a:off x="8261604" y="4146804"/>
-            <a:ext cx="484632" cy="484632"/>
-          </a:xfrm>
-          <a:prstGeom prst="rect">
-            <a:avLst/>
-          </a:prstGeom>
-        </p:spPr>
-      </p:pic>
-      <p:sp>
-        <p:nvSpPr>
-          <p:cNvPr id="25" name="Text 17"/>
-          <p:cNvSpPr txBox="1"/>
-          <p:nvPr/>
-        </p:nvSpPr>
-        <p:spPr>
-          <a:xfrm>
-            <a:off x="9144000" y="3959352"/>
-            <a:ext cx="2240280" cy="457200"/>
-          </a:xfrm>
-          <a:prstGeom prst="rect">
-            <a:avLst/>
-          </a:prstGeom>
-          <a:noFill/>
-          <a:ln/>
-        </p:spPr>
-        <p:txBody>
-          <a:bodyPr wrap="square" lIns="0" tIns="0" rIns="0" bIns="0" rtlCol="0" anchor="b"/>
-          <a:lstStyle/>
-          <a:p>
-            <a:pPr marL="0" indent="0">
-              <a:buNone/>
-            </a:pPr>
-            <a:r>
-              <a:rPr lang="en-US" sz="1400" b="1" dirty="0">
-                <a:solidFill>
-                  <a:srgbClr val="0B2027"/>
-                </a:solidFill>
-                <a:latin typeface="Cambria" pitchFamily="34" charset="0"/>
-                <a:ea typeface="Cambria" pitchFamily="34" charset="-122"/>
-                <a:cs typeface="Cambria" pitchFamily="34" charset="-120"/>
-              </a:rPr>
-              <a:t>Persistencia en JSON</a:t>
-            </a:r>
-            <a:endParaRPr lang="en-US" sz="1400" dirty="0"/>
-          </a:p>
-        </p:txBody>
-      </p:sp>
-      <p:sp>
-        <p:nvSpPr>
-          <p:cNvPr id="26" name="Text 18"/>
-          <p:cNvSpPr txBox="1"/>
-          <p:nvPr/>
-        </p:nvSpPr>
-        <p:spPr>
-          <a:xfrm>
-            <a:off x="9144000" y="4416552"/>
-            <a:ext cx="2240280" cy="1005840"/>
-          </a:xfrm>
-          <a:prstGeom prst="rect">
-            <a:avLst/>
-          </a:prstGeom>
-          <a:noFill/>
-          <a:ln/>
-        </p:spPr>
-        <p:txBody>
-          <a:bodyPr wrap="square" lIns="0" tIns="0" rIns="0" bIns="0" rtlCol="0" anchor="t"/>
-          <a:lstStyle/>
-          <a:p>
-            <a:pPr marL="0" indent="0">
-              <a:lnSpc>
-                <a:spcPct val="115000"/>
-              </a:lnSpc>
-              <a:buNone/>
-            </a:pPr>
-            <a:r>
-              <a:rPr lang="en-US" sz="1150" dirty="0">
-                <a:solidFill>
-                  <a:srgbClr val="4C6B70"/>
-                </a:solidFill>
-                <a:latin typeface="Calibri" pitchFamily="34" charset="0"/>
-                <a:ea typeface="Calibri" pitchFamily="34" charset="-122"/>
-                <a:cs typeface="Calibri" pitchFamily="34" charset="-120"/>
-              </a:rPr>
-              <a:t>Para que los datos no se pierdan entre una ejecución y otra.</a:t>
-            </a:r>
-            <a:endParaRPr lang="en-US" sz="1150" dirty="0"/>
-          </a:p>
-        </p:txBody>
-      </p:sp>
-      <p:sp>
-        <p:nvSpPr>
           <p:cNvPr id="27" name="Text 19"/>
           <p:cNvSpPr txBox="1"/>
           <p:nvPr/>
@@ -5693,7 +3505,7 @@
 </p:sld>
 </file>
 
-<file path=ppt/slides/slide6.xml><?xml version="1.0" encoding="utf-8"?>
+<file path=ppt/slides/slide5.xml><?xml version="1.0" encoding="utf-8"?>
 <p:sld xmlns:a="http://schemas.openxmlformats.org/drawingml/2006/main" xmlns:r="http://schemas.openxmlformats.org/officeDocument/2006/relationships" xmlns:p="http://schemas.openxmlformats.org/presentationml/2006/main">
   <p:cSld name="Slide 6">
     <p:bg>
@@ -6386,7 +4198,7 @@
 </p:sld>
 </file>
 
-<file path=ppt/slides/slide7.xml><?xml version="1.0" encoding="utf-8"?>
+<file path=ppt/slides/slide6.xml><?xml version="1.0" encoding="utf-8"?>
 <p:sld xmlns:a="http://schemas.openxmlformats.org/drawingml/2006/main" xmlns:r="http://schemas.openxmlformats.org/officeDocument/2006/relationships" xmlns:p="http://schemas.openxmlformats.org/presentationml/2006/main">
   <p:cSld name="Slide 7">
     <p:bg>
@@ -6491,13 +4303,13 @@
       </p:sp>
       <p:sp>
         <p:nvSpPr>
-          <p:cNvPr id="4" name="Shape 2"/>
+          <p:cNvPr id="7" name="Shape 4"/>
           <p:cNvSpPr/>
           <p:nvPr/>
         </p:nvSpPr>
         <p:spPr>
           <a:xfrm>
-            <a:off x="621792" y="1837944"/>
+            <a:off x="621792" y="3255264"/>
             <a:ext cx="329184" cy="329184"/>
           </a:xfrm>
           <a:prstGeom prst="ellipse">
@@ -6518,7 +4330,7 @@
       </p:sp>
       <p:pic>
         <p:nvPicPr>
-          <p:cNvPr id="5" name="Image 0" descr="icons/check.png"/>
+          <p:cNvPr id="8" name="Image 1" descr="icons/check.png"/>
           <p:cNvPicPr>
             <a:picLocks noChangeAspect="1"/>
           </p:cNvPicPr>
@@ -6532,7 +4344,7 @@
         </p:blipFill>
         <p:spPr>
           <a:xfrm>
-            <a:off x="704088" y="1920240"/>
+            <a:off x="704088" y="3337560"/>
             <a:ext cx="164592" cy="164592"/>
           </a:xfrm>
           <a:prstGeom prst="rect">
@@ -6542,13 +4354,13 @@
       </p:pic>
       <p:sp>
         <p:nvSpPr>
-          <p:cNvPr id="6" name="Text 3"/>
+          <p:cNvPr id="9" name="Text 5"/>
           <p:cNvSpPr txBox="1"/>
           <p:nvPr/>
         </p:nvSpPr>
         <p:spPr>
           <a:xfrm>
-            <a:off x="1143000" y="1828800"/>
+            <a:off x="1143000" y="3246120"/>
             <a:ext cx="5029200" cy="685800"/>
           </a:xfrm>
           <a:prstGeom prst="rect">
@@ -6576,7 +4388,7 @@
                 <a:ea typeface="Calibri" pitchFamily="34" charset="-122"/>
                 <a:cs typeface="Calibri" pitchFamily="34" charset="-120"/>
               </a:rPr>
-              <a:t>Login con usuario/contraseña y menú distinto por rol</a:t>
+              <a:t>ABM de médicos (alta, baja, modificación, búsqueda y listado)</a:t>
             </a:r>
             <a:endParaRPr lang="en-US" sz="1400" dirty="0"/>
           </a:p>
@@ -6584,13 +4396,13 @@
       </p:sp>
       <p:sp>
         <p:nvSpPr>
-          <p:cNvPr id="7" name="Shape 4"/>
+          <p:cNvPr id="10" name="Shape 6"/>
           <p:cNvSpPr/>
           <p:nvPr/>
         </p:nvSpPr>
         <p:spPr>
           <a:xfrm>
-            <a:off x="621792" y="3255264"/>
+            <a:off x="621792" y="4672584"/>
             <a:ext cx="329184" cy="329184"/>
           </a:xfrm>
           <a:prstGeom prst="ellipse">
@@ -6611,7 +4423,7 @@
       </p:sp>
       <p:pic>
         <p:nvPicPr>
-          <p:cNvPr id="8" name="Image 1" descr="icons/check.png"/>
+          <p:cNvPr id="11" name="Image 2" descr="icons/check.png"/>
           <p:cNvPicPr>
             <a:picLocks noChangeAspect="1"/>
           </p:cNvPicPr>
@@ -6625,7 +4437,7 @@
         </p:blipFill>
         <p:spPr>
           <a:xfrm>
-            <a:off x="704088" y="3337560"/>
+            <a:off x="704088" y="4754880"/>
             <a:ext cx="164592" cy="164592"/>
           </a:xfrm>
           <a:prstGeom prst="rect">
@@ -6635,13 +4447,13 @@
       </p:pic>
       <p:sp>
         <p:nvSpPr>
-          <p:cNvPr id="9" name="Text 5"/>
+          <p:cNvPr id="12" name="Text 7"/>
           <p:cNvSpPr txBox="1"/>
           <p:nvPr/>
         </p:nvSpPr>
         <p:spPr>
           <a:xfrm>
-            <a:off x="1143000" y="3246120"/>
+            <a:off x="1143000" y="4663440"/>
             <a:ext cx="5029200" cy="685800"/>
           </a:xfrm>
           <a:prstGeom prst="rect">
@@ -6669,7 +4481,29 @@
                 <a:ea typeface="Calibri" pitchFamily="34" charset="-122"/>
                 <a:cs typeface="Calibri" pitchFamily="34" charset="-120"/>
               </a:rPr>
-              <a:t>ABM de especialidades, médicos y obras sociales</a:t>
+              <a:t>ABM de </a:t>
+            </a:r>
+            <a:r>
+              <a:rPr lang="en-US" sz="1400" dirty="0" err="1">
+                <a:solidFill>
+                  <a:srgbClr val="0B2027"/>
+                </a:solidFill>
+                <a:latin typeface="Calibri" pitchFamily="34" charset="0"/>
+                <a:ea typeface="Calibri" pitchFamily="34" charset="-122"/>
+                <a:cs typeface="Calibri" pitchFamily="34" charset="-120"/>
+              </a:rPr>
+              <a:t>pacientes</a:t>
+            </a:r>
+            <a:r>
+              <a:rPr lang="en-US" sz="1400" dirty="0">
+                <a:solidFill>
+                  <a:srgbClr val="0B2027"/>
+                </a:solidFill>
+                <a:latin typeface="Calibri" pitchFamily="34" charset="0"/>
+                <a:ea typeface="Calibri" pitchFamily="34" charset="-122"/>
+                <a:cs typeface="Calibri" pitchFamily="34" charset="-120"/>
+              </a:rPr>
+              <a:t> (CUIT como identificador único)</a:t>
             </a:r>
             <a:endParaRPr lang="en-US" sz="1400" dirty="0"/>
           </a:p>
@@ -6677,13 +4511,13 @@
       </p:sp>
       <p:sp>
         <p:nvSpPr>
-          <p:cNvPr id="10" name="Shape 6"/>
+          <p:cNvPr id="13" name="Shape 8"/>
           <p:cNvSpPr/>
           <p:nvPr/>
         </p:nvSpPr>
         <p:spPr>
           <a:xfrm>
-            <a:off x="621792" y="4672584"/>
+            <a:off x="647329" y="1755648"/>
             <a:ext cx="329184" cy="329184"/>
           </a:xfrm>
           <a:prstGeom prst="ellipse">
@@ -6704,7 +4538,7 @@
       </p:sp>
       <p:pic>
         <p:nvPicPr>
-          <p:cNvPr id="11" name="Image 2" descr="icons/check.png"/>
+          <p:cNvPr id="14" name="Image 3" descr="icons/check.png"/>
           <p:cNvPicPr>
             <a:picLocks noChangeAspect="1"/>
           </p:cNvPicPr>
@@ -6718,7 +4552,7 @@
         </p:blipFill>
         <p:spPr>
           <a:xfrm>
-            <a:off x="704088" y="4754880"/>
+            <a:off x="726866" y="1837944"/>
             <a:ext cx="164592" cy="164592"/>
           </a:xfrm>
           <a:prstGeom prst="rect">
@@ -6728,13 +4562,13 @@
       </p:pic>
       <p:sp>
         <p:nvSpPr>
-          <p:cNvPr id="12" name="Text 7"/>
+          <p:cNvPr id="15" name="Text 9"/>
           <p:cNvSpPr txBox="1"/>
           <p:nvPr/>
         </p:nvSpPr>
         <p:spPr>
           <a:xfrm>
-            <a:off x="1143000" y="4663440"/>
+            <a:off x="1143000" y="1810512"/>
             <a:ext cx="5029200" cy="685800"/>
           </a:xfrm>
           <a:prstGeom prst="rect">
@@ -6762,7 +4596,7 @@
                 <a:ea typeface="Calibri" pitchFamily="34" charset="-122"/>
                 <a:cs typeface="Calibri" pitchFamily="34" charset="-120"/>
               </a:rPr>
-              <a:t>ABM de pacientes (DNI como identificador único)</a:t>
+              <a:t>Asignación de turnos validando disponibilidad y horario del médico</a:t>
             </a:r>
             <a:endParaRPr lang="en-US" sz="1400" dirty="0"/>
           </a:p>
@@ -6770,13 +4604,13 @@
       </p:sp>
       <p:sp>
         <p:nvSpPr>
-          <p:cNvPr id="13" name="Shape 8"/>
+          <p:cNvPr id="24" name="Shape 16"/>
           <p:cNvSpPr/>
           <p:nvPr/>
         </p:nvSpPr>
         <p:spPr>
           <a:xfrm>
-            <a:off x="6245352" y="1837944"/>
+            <a:off x="6245352" y="1755648"/>
             <a:ext cx="329184" cy="329184"/>
           </a:xfrm>
           <a:prstGeom prst="ellipse">
@@ -6797,7 +4631,7 @@
       </p:sp>
       <p:pic>
         <p:nvPicPr>
-          <p:cNvPr id="14" name="Image 3" descr="icons/check.png"/>
+          <p:cNvPr id="25" name="Image 6" descr="icons/check.png"/>
           <p:cNvPicPr>
             <a:picLocks noChangeAspect="1"/>
           </p:cNvPicPr>
@@ -6811,7 +4645,7 @@
         </p:blipFill>
         <p:spPr>
           <a:xfrm>
-            <a:off x="6327648" y="1920240"/>
+            <a:off x="6327648" y="1837944"/>
             <a:ext cx="164592" cy="164592"/>
           </a:xfrm>
           <a:prstGeom prst="rect">
@@ -6821,13 +4655,13 @@
       </p:pic>
       <p:sp>
         <p:nvSpPr>
-          <p:cNvPr id="15" name="Text 9"/>
+          <p:cNvPr id="26" name="Text 17"/>
           <p:cNvSpPr txBox="1"/>
           <p:nvPr/>
         </p:nvSpPr>
         <p:spPr>
           <a:xfrm>
-            <a:off x="6766560" y="1828800"/>
+            <a:off x="6766560" y="1810512"/>
             <a:ext cx="5029200" cy="685800"/>
           </a:xfrm>
           <a:prstGeom prst="rect">
@@ -6855,7 +4689,7 @@
                 <a:ea typeface="Calibri" pitchFamily="34" charset="-122"/>
                 <a:cs typeface="Calibri" pitchFamily="34" charset="-120"/>
               </a:rPr>
-              <a:t>Asignación de turnos validando disponibilidad y horario del médico</a:t>
+              <a:t>Modificación y eliminación de turnos existentes</a:t>
             </a:r>
             <a:endParaRPr lang="en-US" sz="1400" dirty="0"/>
           </a:p>
@@ -6948,7 +4782,7 @@
                 <a:ea typeface="Calibri" pitchFamily="34" charset="-122"/>
                 <a:cs typeface="Calibri" pitchFamily="34" charset="-120"/>
               </a:rPr>
-              <a:t>Consulta de agenda filtrable por médico, especialidad y fecha</a:t>
+              <a:t>Listado de todos los turnos cargados</a:t>
             </a:r>
             <a:endParaRPr lang="en-US" sz="1400" dirty="0"/>
           </a:p>
@@ -7041,7 +4875,7 @@
                 <a:ea typeface="Calibri" pitchFamily="34" charset="-122"/>
                 <a:cs typeface="Calibri" pitchFamily="34" charset="-120"/>
               </a:rPr>
-              <a:t>Validación de todos los datos ingresados por el usuario</a:t>
+              <a:t>Consulta de turnos por paciente y por médico (agenda)</a:t>
             </a:r>
             <a:endParaRPr lang="en-US" sz="1400" dirty="0"/>
           </a:p>
@@ -7120,1839 +4954,6 @@
                 <a:cs typeface="Calibri" pitchFamily="34" charset="-120"/>
               </a:rPr>
               <a:t>7</a:t>
-            </a:r>
-            <a:endParaRPr lang="en-US" sz="900" dirty="0"/>
-          </a:p>
-        </p:txBody>
-      </p:sp>
-    </p:spTree>
-  </p:cSld>
-  <p:clrMapOvr>
-    <a:masterClrMapping/>
-  </p:clrMapOvr>
-</p:sld>
-</file>
-
-<file path=ppt/slides/slide8.xml><?xml version="1.0" encoding="utf-8"?>
-<p:sld xmlns:a="http://schemas.openxmlformats.org/drawingml/2006/main" xmlns:r="http://schemas.openxmlformats.org/officeDocument/2006/relationships" xmlns:p="http://schemas.openxmlformats.org/presentationml/2006/main">
-  <p:cSld name="Slide 8">
-    <p:bg>
-      <p:bgPr>
-        <a:solidFill>
-          <a:srgbClr val="013A40"/>
-        </a:solidFill>
-        <a:effectLst/>
-      </p:bgPr>
-    </p:bg>
-    <p:spTree>
-      <p:nvGrpSpPr>
-        <p:cNvPr id="1" name=""/>
-        <p:cNvGrpSpPr/>
-        <p:nvPr/>
-      </p:nvGrpSpPr>
-      <p:grpSpPr>
-        <a:xfrm>
-          <a:off x="0" y="0"/>
-          <a:ext cx="0" cy="0"/>
-          <a:chOff x="0" y="0"/>
-          <a:chExt cx="0" cy="0"/>
-        </a:xfrm>
-      </p:grpSpPr>
-      <p:sp>
-        <p:nvSpPr>
-          <p:cNvPr id="2" name="Text 0"/>
-          <p:cNvSpPr txBox="1"/>
-          <p:nvPr/>
-        </p:nvSpPr>
-        <p:spPr>
-          <a:xfrm>
-            <a:off x="548640" y="502920"/>
-            <a:ext cx="9144000" cy="548640"/>
-          </a:xfrm>
-          <a:prstGeom prst="rect">
-            <a:avLst/>
-          </a:prstGeom>
-          <a:noFill/>
-          <a:ln/>
-        </p:spPr>
-        <p:txBody>
-          <a:bodyPr wrap="square" lIns="0" tIns="0" rIns="0" bIns="0" rtlCol="0" anchor="ctr"/>
-          <a:lstStyle/>
-          <a:p>
-            <a:pPr marL="0" indent="0">
-              <a:buNone/>
-            </a:pPr>
-            <a:r>
-              <a:rPr lang="en-US" sz="2800" b="1" dirty="0">
-                <a:solidFill>
-                  <a:srgbClr val="FFFFFF"/>
-                </a:solidFill>
-                <a:latin typeface="Cambria" pitchFamily="34" charset="0"/>
-                <a:ea typeface="Cambria" pitchFamily="34" charset="-122"/>
-                <a:cs typeface="Cambria" pitchFamily="34" charset="-120"/>
-              </a:rPr>
-              <a:t>Fuera de esta entrega</a:t>
-            </a:r>
-            <a:endParaRPr lang="en-US" sz="2800" dirty="0"/>
-          </a:p>
-        </p:txBody>
-      </p:sp>
-      <p:sp>
-        <p:nvSpPr>
-          <p:cNvPr id="3" name="Text 1"/>
-          <p:cNvSpPr txBox="1"/>
-          <p:nvPr/>
-        </p:nvSpPr>
-        <p:spPr>
-          <a:xfrm>
-            <a:off x="548640" y="1051560"/>
-            <a:ext cx="9144000" cy="365760"/>
-          </a:xfrm>
-          <a:prstGeom prst="rect">
-            <a:avLst/>
-          </a:prstGeom>
-          <a:noFill/>
-          <a:ln/>
-        </p:spPr>
-        <p:txBody>
-          <a:bodyPr wrap="square" lIns="0" tIns="0" rIns="0" bIns="0" rtlCol="0" anchor="ctr"/>
-          <a:lstStyle/>
-          <a:p>
-            <a:pPr marL="0" indent="0">
-              <a:buNone/>
-            </a:pPr>
-            <a:r>
-              <a:rPr lang="en-US" sz="1400" i="1" dirty="0">
-                <a:solidFill>
-                  <a:srgbClr val="02C39A"/>
-                </a:solidFill>
-                <a:latin typeface="Calibri" pitchFamily="34" charset="0"/>
-                <a:ea typeface="Calibri" pitchFamily="34" charset="-122"/>
-                <a:cs typeface="Calibri" pitchFamily="34" charset="-120"/>
-              </a:rPr>
-              <a:t>Queda para la entrega del 100% — no se evalúa en esta instancia</a:t>
-            </a:r>
-            <a:endParaRPr lang="en-US" sz="1400" dirty="0"/>
-          </a:p>
-        </p:txBody>
-      </p:sp>
-      <p:sp>
-        <p:nvSpPr>
-          <p:cNvPr id="4" name="Shape 2"/>
-          <p:cNvSpPr/>
-          <p:nvPr/>
-        </p:nvSpPr>
-        <p:spPr>
-          <a:xfrm>
-            <a:off x="822960" y="2011680"/>
-            <a:ext cx="512064" cy="512064"/>
-          </a:xfrm>
-          <a:prstGeom prst="ellipse">
-            <a:avLst/>
-          </a:prstGeom>
-          <a:solidFill>
-            <a:srgbClr val="0A4E56"/>
-          </a:solidFill>
-          <a:ln/>
-        </p:spPr>
-        <p:txBody>
-          <a:bodyPr/>
-          <a:lstStyle/>
-          <a:p>
-            <a:endParaRPr lang="es-AR"/>
-          </a:p>
-        </p:txBody>
-      </p:sp>
-      <p:pic>
-        <p:nvPicPr>
-          <p:cNvPr id="5" name="Image 0" descr="icons/ban.png"/>
-          <p:cNvPicPr>
-            <a:picLocks noChangeAspect="1"/>
-          </p:cNvPicPr>
-          <p:nvPr/>
-        </p:nvPicPr>
-        <p:blipFill>
-          <a:blip r:embed="rId3"/>
-          <a:stretch>
-            <a:fillRect/>
-          </a:stretch>
-        </p:blipFill>
-        <p:spPr>
-          <a:xfrm>
-            <a:off x="960120" y="2148840"/>
-            <a:ext cx="237744" cy="237744"/>
-          </a:xfrm>
-          <a:prstGeom prst="rect">
-            <a:avLst/>
-          </a:prstGeom>
-        </p:spPr>
-      </p:pic>
-      <p:sp>
-        <p:nvSpPr>
-          <p:cNvPr id="6" name="Text 3"/>
-          <p:cNvSpPr txBox="1"/>
-          <p:nvPr/>
-        </p:nvSpPr>
-        <p:spPr>
-          <a:xfrm>
-            <a:off x="1463040" y="1965960"/>
-            <a:ext cx="4480560" cy="685800"/>
-          </a:xfrm>
-          <a:prstGeom prst="rect">
-            <a:avLst/>
-          </a:prstGeom>
-          <a:noFill/>
-          <a:ln/>
-        </p:spPr>
-        <p:txBody>
-          <a:bodyPr wrap="square" lIns="0" tIns="0" rIns="0" bIns="0" rtlCol="0" anchor="ctr"/>
-          <a:lstStyle/>
-          <a:p>
-            <a:pPr marL="0" indent="0">
-              <a:buNone/>
-            </a:pPr>
-            <a:r>
-              <a:rPr lang="en-US" sz="1350" dirty="0">
-                <a:solidFill>
-                  <a:srgbClr val="D7ECEA"/>
-                </a:solidFill>
-                <a:latin typeface="Calibri" pitchFamily="34" charset="0"/>
-                <a:ea typeface="Calibri" pitchFamily="34" charset="-122"/>
-                <a:cs typeface="Calibri" pitchFamily="34" charset="-120"/>
-              </a:rPr>
-              <a:t>Cancelación y reprogramación de turnos</a:t>
-            </a:r>
-            <a:endParaRPr lang="en-US" sz="1350" dirty="0"/>
-          </a:p>
-        </p:txBody>
-      </p:sp>
-      <p:sp>
-        <p:nvSpPr>
-          <p:cNvPr id="7" name="Shape 4"/>
-          <p:cNvSpPr/>
-          <p:nvPr/>
-        </p:nvSpPr>
-        <p:spPr>
-          <a:xfrm>
-            <a:off x="822960" y="2880360"/>
-            <a:ext cx="512064" cy="512064"/>
-          </a:xfrm>
-          <a:prstGeom prst="ellipse">
-            <a:avLst/>
-          </a:prstGeom>
-          <a:solidFill>
-            <a:srgbClr val="0A4E56"/>
-          </a:solidFill>
-          <a:ln/>
-        </p:spPr>
-        <p:txBody>
-          <a:bodyPr/>
-          <a:lstStyle/>
-          <a:p>
-            <a:endParaRPr lang="es-AR"/>
-          </a:p>
-        </p:txBody>
-      </p:sp>
-      <p:pic>
-        <p:nvPicPr>
-          <p:cNvPr id="8" name="Image 1" descr="icons/ban.png"/>
-          <p:cNvPicPr>
-            <a:picLocks noChangeAspect="1"/>
-          </p:cNvPicPr>
-          <p:nvPr/>
-        </p:nvPicPr>
-        <p:blipFill>
-          <a:blip r:embed="rId3"/>
-          <a:stretch>
-            <a:fillRect/>
-          </a:stretch>
-        </p:blipFill>
-        <p:spPr>
-          <a:xfrm>
-            <a:off x="960120" y="3017520"/>
-            <a:ext cx="237744" cy="237744"/>
-          </a:xfrm>
-          <a:prstGeom prst="rect">
-            <a:avLst/>
-          </a:prstGeom>
-        </p:spPr>
-      </p:pic>
-      <p:sp>
-        <p:nvSpPr>
-          <p:cNvPr id="9" name="Text 5"/>
-          <p:cNvSpPr txBox="1"/>
-          <p:nvPr/>
-        </p:nvSpPr>
-        <p:spPr>
-          <a:xfrm>
-            <a:off x="1463040" y="2834640"/>
-            <a:ext cx="4480560" cy="685800"/>
-          </a:xfrm>
-          <a:prstGeom prst="rect">
-            <a:avLst/>
-          </a:prstGeom>
-          <a:noFill/>
-          <a:ln/>
-        </p:spPr>
-        <p:txBody>
-          <a:bodyPr wrap="square" lIns="0" tIns="0" rIns="0" bIns="0" rtlCol="0" anchor="ctr"/>
-          <a:lstStyle/>
-          <a:p>
-            <a:pPr marL="0" indent="0">
-              <a:buNone/>
-            </a:pPr>
-            <a:r>
-              <a:rPr lang="en-US" sz="1350" dirty="0">
-                <a:solidFill>
-                  <a:srgbClr val="D7ECEA"/>
-                </a:solidFill>
-                <a:latin typeface="Calibri" pitchFamily="34" charset="0"/>
-                <a:ea typeface="Calibri" pitchFamily="34" charset="-122"/>
-                <a:cs typeface="Calibri" pitchFamily="34" charset="-120"/>
-              </a:rPr>
-              <a:t>Registro de ausencias de pacientes</a:t>
-            </a:r>
-            <a:endParaRPr lang="en-US" sz="1350" dirty="0"/>
-          </a:p>
-        </p:txBody>
-      </p:sp>
-      <p:sp>
-        <p:nvSpPr>
-          <p:cNvPr id="10" name="Shape 6"/>
-          <p:cNvSpPr/>
-          <p:nvPr/>
-        </p:nvSpPr>
-        <p:spPr>
-          <a:xfrm>
-            <a:off x="822960" y="3749040"/>
-            <a:ext cx="512064" cy="512064"/>
-          </a:xfrm>
-          <a:prstGeom prst="ellipse">
-            <a:avLst/>
-          </a:prstGeom>
-          <a:solidFill>
-            <a:srgbClr val="0A4E56"/>
-          </a:solidFill>
-          <a:ln/>
-        </p:spPr>
-        <p:txBody>
-          <a:bodyPr/>
-          <a:lstStyle/>
-          <a:p>
-            <a:endParaRPr lang="es-AR"/>
-          </a:p>
-        </p:txBody>
-      </p:sp>
-      <p:pic>
-        <p:nvPicPr>
-          <p:cNvPr id="11" name="Image 2" descr="icons/ban.png"/>
-          <p:cNvPicPr>
-            <a:picLocks noChangeAspect="1"/>
-          </p:cNvPicPr>
-          <p:nvPr/>
-        </p:nvPicPr>
-        <p:blipFill>
-          <a:blip r:embed="rId3"/>
-          <a:stretch>
-            <a:fillRect/>
-          </a:stretch>
-        </p:blipFill>
-        <p:spPr>
-          <a:xfrm>
-            <a:off x="960120" y="3886200"/>
-            <a:ext cx="237744" cy="237744"/>
-          </a:xfrm>
-          <a:prstGeom prst="rect">
-            <a:avLst/>
-          </a:prstGeom>
-        </p:spPr>
-      </p:pic>
-      <p:sp>
-        <p:nvSpPr>
-          <p:cNvPr id="12" name="Text 7"/>
-          <p:cNvSpPr txBox="1"/>
-          <p:nvPr/>
-        </p:nvSpPr>
-        <p:spPr>
-          <a:xfrm>
-            <a:off x="1463040" y="3703320"/>
-            <a:ext cx="4480560" cy="685800"/>
-          </a:xfrm>
-          <a:prstGeom prst="rect">
-            <a:avLst/>
-          </a:prstGeom>
-          <a:noFill/>
-          <a:ln/>
-        </p:spPr>
-        <p:txBody>
-          <a:bodyPr wrap="square" lIns="0" tIns="0" rIns="0" bIns="0" rtlCol="0" anchor="ctr"/>
-          <a:lstStyle/>
-          <a:p>
-            <a:pPr marL="0" indent="0">
-              <a:buNone/>
-            </a:pPr>
-            <a:r>
-              <a:rPr lang="en-US" sz="1350" dirty="0">
-                <a:solidFill>
-                  <a:srgbClr val="D7ECEA"/>
-                </a:solidFill>
-                <a:latin typeface="Calibri" pitchFamily="34" charset="0"/>
-                <a:ea typeface="Calibri" pitchFamily="34" charset="-122"/>
-                <a:cs typeface="Calibri" pitchFamily="34" charset="-120"/>
-              </a:rPr>
-              <a:t>Agenda propia del médico y marcado de "atendido"</a:t>
-            </a:r>
-            <a:endParaRPr lang="en-US" sz="1350" dirty="0"/>
-          </a:p>
-        </p:txBody>
-      </p:sp>
-      <p:sp>
-        <p:nvSpPr>
-          <p:cNvPr id="13" name="Shape 8"/>
-          <p:cNvSpPr/>
-          <p:nvPr/>
-        </p:nvSpPr>
-        <p:spPr>
-          <a:xfrm>
-            <a:off x="822960" y="4617720"/>
-            <a:ext cx="512064" cy="512064"/>
-          </a:xfrm>
-          <a:prstGeom prst="ellipse">
-            <a:avLst/>
-          </a:prstGeom>
-          <a:solidFill>
-            <a:srgbClr val="0A4E56"/>
-          </a:solidFill>
-          <a:ln/>
-        </p:spPr>
-        <p:txBody>
-          <a:bodyPr/>
-          <a:lstStyle/>
-          <a:p>
-            <a:endParaRPr lang="es-AR"/>
-          </a:p>
-        </p:txBody>
-      </p:sp>
-      <p:pic>
-        <p:nvPicPr>
-          <p:cNvPr id="14" name="Image 3" descr="icons/ban.png"/>
-          <p:cNvPicPr>
-            <a:picLocks noChangeAspect="1"/>
-          </p:cNvPicPr>
-          <p:nvPr/>
-        </p:nvPicPr>
-        <p:blipFill>
-          <a:blip r:embed="rId3"/>
-          <a:stretch>
-            <a:fillRect/>
-          </a:stretch>
-        </p:blipFill>
-        <p:spPr>
-          <a:xfrm>
-            <a:off x="960120" y="4754880"/>
-            <a:ext cx="237744" cy="237744"/>
-          </a:xfrm>
-          <a:prstGeom prst="rect">
-            <a:avLst/>
-          </a:prstGeom>
-        </p:spPr>
-      </p:pic>
-      <p:sp>
-        <p:nvSpPr>
-          <p:cNvPr id="15" name="Text 9"/>
-          <p:cNvSpPr txBox="1"/>
-          <p:nvPr/>
-        </p:nvSpPr>
-        <p:spPr>
-          <a:xfrm>
-            <a:off x="1463040" y="4572000"/>
-            <a:ext cx="4480560" cy="685800"/>
-          </a:xfrm>
-          <a:prstGeom prst="rect">
-            <a:avLst/>
-          </a:prstGeom>
-          <a:noFill/>
-          <a:ln/>
-        </p:spPr>
-        <p:txBody>
-          <a:bodyPr wrap="square" lIns="0" tIns="0" rIns="0" bIns="0" rtlCol="0" anchor="ctr"/>
-          <a:lstStyle/>
-          <a:p>
-            <a:pPr marL="0" indent="0">
-              <a:buNone/>
-            </a:pPr>
-            <a:r>
-              <a:rPr lang="en-US" sz="1350" dirty="0">
-                <a:solidFill>
-                  <a:srgbClr val="D7ECEA"/>
-                </a:solidFill>
-                <a:latin typeface="Calibri" pitchFamily="34" charset="0"/>
-                <a:ea typeface="Calibri" pitchFamily="34" charset="-122"/>
-                <a:cs typeface="Calibri" pitchFamily="34" charset="-120"/>
-              </a:rPr>
-              <a:t>Historial de pacientes atendidos</a:t>
-            </a:r>
-            <a:endParaRPr lang="en-US" sz="1350" dirty="0"/>
-          </a:p>
-        </p:txBody>
-      </p:sp>
-      <p:sp>
-        <p:nvSpPr>
-          <p:cNvPr id="16" name="Shape 10"/>
-          <p:cNvSpPr/>
-          <p:nvPr/>
-        </p:nvSpPr>
-        <p:spPr>
-          <a:xfrm>
-            <a:off x="6400800" y="2011680"/>
-            <a:ext cx="512064" cy="512064"/>
-          </a:xfrm>
-          <a:prstGeom prst="ellipse">
-            <a:avLst/>
-          </a:prstGeom>
-          <a:solidFill>
-            <a:srgbClr val="0A4E56"/>
-          </a:solidFill>
-          <a:ln/>
-        </p:spPr>
-        <p:txBody>
-          <a:bodyPr/>
-          <a:lstStyle/>
-          <a:p>
-            <a:endParaRPr lang="es-AR"/>
-          </a:p>
-        </p:txBody>
-      </p:sp>
-      <p:pic>
-        <p:nvPicPr>
-          <p:cNvPr id="17" name="Image 4" descr="icons/ban.png"/>
-          <p:cNvPicPr>
-            <a:picLocks noChangeAspect="1"/>
-          </p:cNvPicPr>
-          <p:nvPr/>
-        </p:nvPicPr>
-        <p:blipFill>
-          <a:blip r:embed="rId3"/>
-          <a:stretch>
-            <a:fillRect/>
-          </a:stretch>
-        </p:blipFill>
-        <p:spPr>
-          <a:xfrm>
-            <a:off x="6537960" y="2148840"/>
-            <a:ext cx="237744" cy="237744"/>
-          </a:xfrm>
-          <a:prstGeom prst="rect">
-            <a:avLst/>
-          </a:prstGeom>
-        </p:spPr>
-      </p:pic>
-      <p:sp>
-        <p:nvSpPr>
-          <p:cNvPr id="18" name="Text 11"/>
-          <p:cNvSpPr txBox="1"/>
-          <p:nvPr/>
-        </p:nvSpPr>
-        <p:spPr>
-          <a:xfrm>
-            <a:off x="7040880" y="1965960"/>
-            <a:ext cx="4480560" cy="685800"/>
-          </a:xfrm>
-          <a:prstGeom prst="rect">
-            <a:avLst/>
-          </a:prstGeom>
-          <a:noFill/>
-          <a:ln/>
-        </p:spPr>
-        <p:txBody>
-          <a:bodyPr wrap="square" lIns="0" tIns="0" rIns="0" bIns="0" rtlCol="0" anchor="ctr"/>
-          <a:lstStyle/>
-          <a:p>
-            <a:pPr marL="0" indent="0">
-              <a:buNone/>
-            </a:pPr>
-            <a:r>
-              <a:rPr lang="en-US" sz="1350" dirty="0">
-                <a:solidFill>
-                  <a:srgbClr val="D7ECEA"/>
-                </a:solidFill>
-                <a:latin typeface="Calibri" pitchFamily="34" charset="0"/>
-                <a:ea typeface="Calibri" pitchFamily="34" charset="-122"/>
-                <a:cs typeface="Calibri" pitchFamily="34" charset="-120"/>
-              </a:rPr>
-              <a:t>ABM de usuarios del sistema</a:t>
-            </a:r>
-            <a:endParaRPr lang="en-US" sz="1350" dirty="0"/>
-          </a:p>
-        </p:txBody>
-      </p:sp>
-      <p:sp>
-        <p:nvSpPr>
-          <p:cNvPr id="19" name="Shape 12"/>
-          <p:cNvSpPr/>
-          <p:nvPr/>
-        </p:nvSpPr>
-        <p:spPr>
-          <a:xfrm>
-            <a:off x="6400800" y="2880360"/>
-            <a:ext cx="512064" cy="512064"/>
-          </a:xfrm>
-          <a:prstGeom prst="ellipse">
-            <a:avLst/>
-          </a:prstGeom>
-          <a:solidFill>
-            <a:srgbClr val="0A4E56"/>
-          </a:solidFill>
-          <a:ln/>
-        </p:spPr>
-        <p:txBody>
-          <a:bodyPr/>
-          <a:lstStyle/>
-          <a:p>
-            <a:endParaRPr lang="es-AR"/>
-          </a:p>
-        </p:txBody>
-      </p:sp>
-      <p:pic>
-        <p:nvPicPr>
-          <p:cNvPr id="20" name="Image 5" descr="icons/ban.png"/>
-          <p:cNvPicPr>
-            <a:picLocks noChangeAspect="1"/>
-          </p:cNvPicPr>
-          <p:nvPr/>
-        </p:nvPicPr>
-        <p:blipFill>
-          <a:blip r:embed="rId3"/>
-          <a:stretch>
-            <a:fillRect/>
-          </a:stretch>
-        </p:blipFill>
-        <p:spPr>
-          <a:xfrm>
-            <a:off x="6537960" y="3017520"/>
-            <a:ext cx="237744" cy="237744"/>
-          </a:xfrm>
-          <a:prstGeom prst="rect">
-            <a:avLst/>
-          </a:prstGeom>
-        </p:spPr>
-      </p:pic>
-      <p:sp>
-        <p:nvSpPr>
-          <p:cNvPr id="21" name="Text 13"/>
-          <p:cNvSpPr txBox="1"/>
-          <p:nvPr/>
-        </p:nvSpPr>
-        <p:spPr>
-          <a:xfrm>
-            <a:off x="7040880" y="2834640"/>
-            <a:ext cx="4480560" cy="685800"/>
-          </a:xfrm>
-          <a:prstGeom prst="rect">
-            <a:avLst/>
-          </a:prstGeom>
-          <a:noFill/>
-          <a:ln/>
-        </p:spPr>
-        <p:txBody>
-          <a:bodyPr wrap="square" lIns="0" tIns="0" rIns="0" bIns="0" rtlCol="0" anchor="ctr"/>
-          <a:lstStyle/>
-          <a:p>
-            <a:pPr marL="0" indent="0">
-              <a:buNone/>
-            </a:pPr>
-            <a:r>
-              <a:rPr lang="en-US" sz="1350" dirty="0">
-                <a:solidFill>
-                  <a:srgbClr val="D7ECEA"/>
-                </a:solidFill>
-                <a:latin typeface="Calibri" pitchFamily="34" charset="0"/>
-                <a:ea typeface="Calibri" pitchFamily="34" charset="-122"/>
-                <a:cs typeface="Calibri" pitchFamily="34" charset="-120"/>
-              </a:rPr>
-              <a:t>Reportes de gestión del administrador</a:t>
-            </a:r>
-            <a:endParaRPr lang="en-US" sz="1350" dirty="0"/>
-          </a:p>
-        </p:txBody>
-      </p:sp>
-      <p:sp>
-        <p:nvSpPr>
-          <p:cNvPr id="22" name="Shape 14"/>
-          <p:cNvSpPr/>
-          <p:nvPr/>
-        </p:nvSpPr>
-        <p:spPr>
-          <a:xfrm>
-            <a:off x="6400800" y="3749040"/>
-            <a:ext cx="512064" cy="512064"/>
-          </a:xfrm>
-          <a:prstGeom prst="ellipse">
-            <a:avLst/>
-          </a:prstGeom>
-          <a:solidFill>
-            <a:srgbClr val="0A4E56"/>
-          </a:solidFill>
-          <a:ln/>
-        </p:spPr>
-        <p:txBody>
-          <a:bodyPr/>
-          <a:lstStyle/>
-          <a:p>
-            <a:endParaRPr lang="es-AR"/>
-          </a:p>
-        </p:txBody>
-      </p:sp>
-      <p:pic>
-        <p:nvPicPr>
-          <p:cNvPr id="23" name="Image 6" descr="icons/ban.png"/>
-          <p:cNvPicPr>
-            <a:picLocks noChangeAspect="1"/>
-          </p:cNvPicPr>
-          <p:nvPr/>
-        </p:nvPicPr>
-        <p:blipFill>
-          <a:blip r:embed="rId3"/>
-          <a:stretch>
-            <a:fillRect/>
-          </a:stretch>
-        </p:blipFill>
-        <p:spPr>
-          <a:xfrm>
-            <a:off x="6537960" y="3886200"/>
-            <a:ext cx="237744" cy="237744"/>
-          </a:xfrm>
-          <a:prstGeom prst="rect">
-            <a:avLst/>
-          </a:prstGeom>
-        </p:spPr>
-      </p:pic>
-      <p:sp>
-        <p:nvSpPr>
-          <p:cNvPr id="24" name="Text 15"/>
-          <p:cNvSpPr txBox="1"/>
-          <p:nvPr/>
-        </p:nvSpPr>
-        <p:spPr>
-          <a:xfrm>
-            <a:off x="7040880" y="3703320"/>
-            <a:ext cx="4480560" cy="685800"/>
-          </a:xfrm>
-          <a:prstGeom prst="rect">
-            <a:avLst/>
-          </a:prstGeom>
-          <a:noFill/>
-          <a:ln/>
-        </p:spPr>
-        <p:txBody>
-          <a:bodyPr wrap="square" lIns="0" tIns="0" rIns="0" bIns="0" rtlCol="0" anchor="ctr"/>
-          <a:lstStyle/>
-          <a:p>
-            <a:pPr marL="0" indent="0">
-              <a:buNone/>
-            </a:pPr>
-            <a:r>
-              <a:rPr lang="en-US" sz="1350" dirty="0">
-                <a:solidFill>
-                  <a:srgbClr val="D7ECEA"/>
-                </a:solidFill>
-                <a:latin typeface="Calibri" pitchFamily="34" charset="0"/>
-                <a:ea typeface="Calibri" pitchFamily="34" charset="-122"/>
-                <a:cs typeface="Calibri" pitchFamily="34" charset="-120"/>
-              </a:rPr>
-              <a:t>Persistencia de datos en archivos JSON</a:t>
-            </a:r>
-            <a:endParaRPr lang="en-US" sz="1350" dirty="0"/>
-          </a:p>
-        </p:txBody>
-      </p:sp>
-      <p:sp>
-        <p:nvSpPr>
-          <p:cNvPr id="25" name="Text 16"/>
-          <p:cNvSpPr txBox="1"/>
-          <p:nvPr/>
-        </p:nvSpPr>
-        <p:spPr>
-          <a:xfrm>
-            <a:off x="457200" y="6473952"/>
-            <a:ext cx="7315200" cy="274320"/>
-          </a:xfrm>
-          <a:prstGeom prst="rect">
-            <a:avLst/>
-          </a:prstGeom>
-          <a:noFill/>
-          <a:ln/>
-        </p:spPr>
-        <p:txBody>
-          <a:bodyPr wrap="square" lIns="0" tIns="0" rIns="0" bIns="0" rtlCol="0" anchor="ctr"/>
-          <a:lstStyle/>
-          <a:p>
-            <a:pPr marL="0" indent="0">
-              <a:buNone/>
-            </a:pPr>
-            <a:r>
-              <a:rPr lang="en-US" sz="900" dirty="0">
-                <a:solidFill>
-                  <a:srgbClr val="BFDDD9"/>
-                </a:solidFill>
-                <a:latin typeface="Calibri" pitchFamily="34" charset="0"/>
-                <a:ea typeface="Calibri" pitchFamily="34" charset="-122"/>
-                <a:cs typeface="Calibri" pitchFamily="34" charset="-120"/>
-              </a:rPr>
-              <a:t>SIGET — Sistema de Gestión de Turnos Médicos</a:t>
-            </a:r>
-            <a:endParaRPr lang="en-US" sz="900" dirty="0"/>
-          </a:p>
-        </p:txBody>
-      </p:sp>
-      <p:sp>
-        <p:nvSpPr>
-          <p:cNvPr id="26" name="Text 17"/>
-          <p:cNvSpPr txBox="1"/>
-          <p:nvPr/>
-        </p:nvSpPr>
-        <p:spPr>
-          <a:xfrm>
-            <a:off x="11274552" y="6473952"/>
-            <a:ext cx="457200" cy="274320"/>
-          </a:xfrm>
-          <a:prstGeom prst="rect">
-            <a:avLst/>
-          </a:prstGeom>
-          <a:noFill/>
-          <a:ln/>
-        </p:spPr>
-        <p:txBody>
-          <a:bodyPr wrap="square" lIns="0" tIns="0" rIns="0" bIns="0" rtlCol="0" anchor="ctr"/>
-          <a:lstStyle/>
-          <a:p>
-            <a:pPr marL="0" indent="0" algn="r">
-              <a:buNone/>
-            </a:pPr>
-            <a:r>
-              <a:rPr lang="en-US" sz="900" dirty="0">
-                <a:solidFill>
-                  <a:srgbClr val="BFDDD9"/>
-                </a:solidFill>
-                <a:latin typeface="Calibri" pitchFamily="34" charset="0"/>
-                <a:ea typeface="Calibri" pitchFamily="34" charset="-122"/>
-                <a:cs typeface="Calibri" pitchFamily="34" charset="-120"/>
-              </a:rPr>
-              <a:t>8</a:t>
-            </a:r>
-            <a:endParaRPr lang="en-US" sz="900" dirty="0"/>
-          </a:p>
-        </p:txBody>
-      </p:sp>
-    </p:spTree>
-  </p:cSld>
-  <p:clrMapOvr>
-    <a:masterClrMapping/>
-  </p:clrMapOvr>
-</p:sld>
-</file>
-
-<file path=ppt/slides/slide9.xml><?xml version="1.0" encoding="utf-8"?>
-<p:sld xmlns:a="http://schemas.openxmlformats.org/drawingml/2006/main" xmlns:r="http://schemas.openxmlformats.org/officeDocument/2006/relationships" xmlns:p="http://schemas.openxmlformats.org/presentationml/2006/main">
-  <p:cSld name="Slide 9">
-    <p:bg>
-      <p:bgPr>
-        <a:solidFill>
-          <a:srgbClr val="F4FAF9"/>
-        </a:solidFill>
-        <a:effectLst/>
-      </p:bgPr>
-    </p:bg>
-    <p:spTree>
-      <p:nvGrpSpPr>
-        <p:cNvPr id="1" name=""/>
-        <p:cNvGrpSpPr/>
-        <p:nvPr/>
-      </p:nvGrpSpPr>
-      <p:grpSpPr>
-        <a:xfrm>
-          <a:off x="0" y="0"/>
-          <a:ext cx="0" cy="0"/>
-          <a:chOff x="0" y="0"/>
-          <a:chExt cx="0" cy="0"/>
-        </a:xfrm>
-      </p:grpSpPr>
-      <p:sp>
-        <p:nvSpPr>
-          <p:cNvPr id="2" name="Text 0"/>
-          <p:cNvSpPr txBox="1"/>
-          <p:nvPr/>
-        </p:nvSpPr>
-        <p:spPr>
-          <a:xfrm>
-            <a:off x="548640" y="457200"/>
-            <a:ext cx="9144000" cy="640080"/>
-          </a:xfrm>
-          <a:prstGeom prst="rect">
-            <a:avLst/>
-          </a:prstGeom>
-          <a:noFill/>
-          <a:ln/>
-        </p:spPr>
-        <p:txBody>
-          <a:bodyPr wrap="square" lIns="0" tIns="0" rIns="0" bIns="0" rtlCol="0" anchor="ctr"/>
-          <a:lstStyle/>
-          <a:p>
-            <a:pPr marL="0" indent="0">
-              <a:buNone/>
-            </a:pPr>
-            <a:r>
-              <a:rPr lang="en-US" sz="3200" b="1" dirty="0">
-                <a:solidFill>
-                  <a:srgbClr val="0B2027"/>
-                </a:solidFill>
-                <a:latin typeface="Cambria" pitchFamily="34" charset="0"/>
-                <a:ea typeface="Cambria" pitchFamily="34" charset="-122"/>
-                <a:cs typeface="Cambria" pitchFamily="34" charset="-120"/>
-              </a:rPr>
-              <a:t>Camino a la entrega final</a:t>
-            </a:r>
-            <a:endParaRPr lang="en-US" sz="3200" dirty="0"/>
-          </a:p>
-        </p:txBody>
-      </p:sp>
-      <p:sp>
-        <p:nvSpPr>
-          <p:cNvPr id="3" name="Shape 1"/>
-          <p:cNvSpPr/>
-          <p:nvPr/>
-        </p:nvSpPr>
-        <p:spPr>
-          <a:xfrm>
-            <a:off x="10287000" y="457200"/>
-            <a:ext cx="822960" cy="822960"/>
-          </a:xfrm>
-          <a:prstGeom prst="ellipse">
-            <a:avLst/>
-          </a:prstGeom>
-          <a:solidFill>
-            <a:srgbClr val="028090"/>
-          </a:solidFill>
-          <a:ln/>
-        </p:spPr>
-        <p:txBody>
-          <a:bodyPr/>
-          <a:lstStyle/>
-          <a:p>
-            <a:endParaRPr lang="es-AR"/>
-          </a:p>
-        </p:txBody>
-      </p:sp>
-      <p:pic>
-        <p:nvPicPr>
-          <p:cNvPr id="4" name="Image 0" descr="icons/road.png"/>
-          <p:cNvPicPr>
-            <a:picLocks noChangeAspect="1"/>
-          </p:cNvPicPr>
-          <p:nvPr/>
-        </p:nvPicPr>
-        <p:blipFill>
-          <a:blip r:embed="rId3"/>
-          <a:stretch>
-            <a:fillRect/>
-          </a:stretch>
-        </p:blipFill>
-        <p:spPr>
-          <a:xfrm>
-            <a:off x="10488168" y="658368"/>
-            <a:ext cx="420624" cy="420624"/>
-          </a:xfrm>
-          <a:prstGeom prst="rect">
-            <a:avLst/>
-          </a:prstGeom>
-        </p:spPr>
-      </p:pic>
-      <p:sp>
-        <p:nvSpPr>
-          <p:cNvPr id="5" name="Shape 2"/>
-          <p:cNvSpPr/>
-          <p:nvPr/>
-        </p:nvSpPr>
-        <p:spPr>
-          <a:xfrm>
-            <a:off x="640080" y="1920240"/>
-            <a:ext cx="2606040" cy="3840480"/>
-          </a:xfrm>
-          <a:prstGeom prst="roundRect">
-            <a:avLst>
-              <a:gd name="adj" fmla="val 3509"/>
-            </a:avLst>
-          </a:prstGeom>
-          <a:solidFill>
-            <a:srgbClr val="FFFFFF"/>
-          </a:solidFill>
-          <a:ln/>
-          <a:effectLst>
-            <a:outerShdw blurRad="76200" dist="25400" dir="5400000" algn="bl" rotWithShape="0">
-              <a:srgbClr val="0B2027">
-                <a:alpha val="10000"/>
-              </a:srgbClr>
-            </a:outerShdw>
-          </a:effectLst>
-        </p:spPr>
-        <p:txBody>
-          <a:bodyPr/>
-          <a:lstStyle/>
-          <a:p>
-            <a:endParaRPr lang="es-AR"/>
-          </a:p>
-        </p:txBody>
-      </p:sp>
-      <p:sp>
-        <p:nvSpPr>
-          <p:cNvPr id="6" name="Shape 3"/>
-          <p:cNvSpPr/>
-          <p:nvPr/>
-        </p:nvSpPr>
-        <p:spPr>
-          <a:xfrm>
-            <a:off x="868680" y="2194560"/>
-            <a:ext cx="502920" cy="502920"/>
-          </a:xfrm>
-          <a:prstGeom prst="ellipse">
-            <a:avLst/>
-          </a:prstGeom>
-          <a:solidFill>
-            <a:srgbClr val="00A896"/>
-          </a:solidFill>
-          <a:ln/>
-        </p:spPr>
-        <p:txBody>
-          <a:bodyPr/>
-          <a:lstStyle/>
-          <a:p>
-            <a:endParaRPr lang="es-AR"/>
-          </a:p>
-        </p:txBody>
-      </p:sp>
-      <p:sp>
-        <p:nvSpPr>
-          <p:cNvPr id="7" name="Text 4"/>
-          <p:cNvSpPr txBox="1"/>
-          <p:nvPr/>
-        </p:nvSpPr>
-        <p:spPr>
-          <a:xfrm>
-            <a:off x="868680" y="2194560"/>
-            <a:ext cx="502920" cy="502920"/>
-          </a:xfrm>
-          <a:prstGeom prst="rect">
-            <a:avLst/>
-          </a:prstGeom>
-          <a:noFill/>
-          <a:ln/>
-        </p:spPr>
-        <p:txBody>
-          <a:bodyPr wrap="square" lIns="0" tIns="0" rIns="0" bIns="0" rtlCol="0" anchor="ctr"/>
-          <a:lstStyle/>
-          <a:p>
-            <a:pPr marL="0" indent="0" algn="ctr">
-              <a:buNone/>
-            </a:pPr>
-            <a:r>
-              <a:rPr lang="en-US" sz="1800" b="1" dirty="0">
-                <a:solidFill>
-                  <a:srgbClr val="FFFFFF"/>
-                </a:solidFill>
-                <a:latin typeface="Cambria" pitchFamily="34" charset="0"/>
-                <a:ea typeface="Cambria" pitchFamily="34" charset="-122"/>
-                <a:cs typeface="Cambria" pitchFamily="34" charset="-120"/>
-              </a:rPr>
-              <a:t>1</a:t>
-            </a:r>
-            <a:endParaRPr lang="en-US" sz="1800" dirty="0"/>
-          </a:p>
-        </p:txBody>
-      </p:sp>
-      <p:sp>
-        <p:nvSpPr>
-          <p:cNvPr id="8" name="Text 5"/>
-          <p:cNvSpPr txBox="1"/>
-          <p:nvPr/>
-        </p:nvSpPr>
-        <p:spPr>
-          <a:xfrm>
-            <a:off x="841248" y="2880360"/>
-            <a:ext cx="2203704" cy="777240"/>
-          </a:xfrm>
-          <a:prstGeom prst="rect">
-            <a:avLst/>
-          </a:prstGeom>
-          <a:noFill/>
-          <a:ln/>
-        </p:spPr>
-        <p:txBody>
-          <a:bodyPr wrap="square" lIns="0" tIns="0" rIns="0" bIns="0" rtlCol="0" anchor="t"/>
-          <a:lstStyle/>
-          <a:p>
-            <a:pPr marL="0" indent="0">
-              <a:buNone/>
-            </a:pPr>
-            <a:r>
-              <a:rPr lang="en-US" sz="1350" b="1" dirty="0">
-                <a:solidFill>
-                  <a:srgbClr val="0B2027"/>
-                </a:solidFill>
-                <a:latin typeface="Cambria" pitchFamily="34" charset="0"/>
-                <a:ea typeface="Cambria" pitchFamily="34" charset="-122"/>
-                <a:cs typeface="Cambria" pitchFamily="34" charset="-120"/>
-              </a:rPr>
-              <a:t>Gestión completa del turno</a:t>
-            </a:r>
-            <a:endParaRPr lang="en-US" sz="1350" dirty="0"/>
-          </a:p>
-        </p:txBody>
-      </p:sp>
-      <p:sp>
-        <p:nvSpPr>
-          <p:cNvPr id="9" name="Text 6"/>
-          <p:cNvSpPr txBox="1"/>
-          <p:nvPr/>
-        </p:nvSpPr>
-        <p:spPr>
-          <a:xfrm>
-            <a:off x="841248" y="3703320"/>
-            <a:ext cx="2203704" cy="1920240"/>
-          </a:xfrm>
-          <a:prstGeom prst="rect">
-            <a:avLst/>
-          </a:prstGeom>
-          <a:noFill/>
-          <a:ln/>
-        </p:spPr>
-        <p:txBody>
-          <a:bodyPr wrap="square" lIns="0" tIns="0" rIns="0" bIns="0" rtlCol="0" anchor="t"/>
-          <a:lstStyle/>
-          <a:p>
-            <a:pPr marL="0" indent="0">
-              <a:lnSpc>
-                <a:spcPct val="120000"/>
-              </a:lnSpc>
-              <a:buNone/>
-            </a:pPr>
-            <a:r>
-              <a:rPr lang="en-US" sz="1100" dirty="0">
-                <a:solidFill>
-                  <a:srgbClr val="4C6B70"/>
-                </a:solidFill>
-                <a:latin typeface="Calibri" pitchFamily="34" charset="0"/>
-                <a:ea typeface="Calibri" pitchFamily="34" charset="-122"/>
-                <a:cs typeface="Calibri" pitchFamily="34" charset="-120"/>
-              </a:rPr>
-              <a:t>Cancelación, reprogramación y registro de ausencias.</a:t>
-            </a:r>
-            <a:endParaRPr lang="en-US" sz="1100" dirty="0"/>
-          </a:p>
-        </p:txBody>
-      </p:sp>
-      <p:sp>
-        <p:nvSpPr>
-          <p:cNvPr id="10" name="Shape 7"/>
-          <p:cNvSpPr/>
-          <p:nvPr/>
-        </p:nvSpPr>
-        <p:spPr>
-          <a:xfrm>
-            <a:off x="3273552" y="3749040"/>
-            <a:ext cx="109728" cy="109728"/>
-          </a:xfrm>
-          <a:prstGeom prst="ellipse">
-            <a:avLst/>
-          </a:prstGeom>
-          <a:solidFill>
-            <a:srgbClr val="028090"/>
-          </a:solidFill>
-          <a:ln/>
-        </p:spPr>
-        <p:txBody>
-          <a:bodyPr/>
-          <a:lstStyle/>
-          <a:p>
-            <a:endParaRPr lang="es-AR"/>
-          </a:p>
-        </p:txBody>
-      </p:sp>
-      <p:sp>
-        <p:nvSpPr>
-          <p:cNvPr id="11" name="Shape 8"/>
-          <p:cNvSpPr/>
-          <p:nvPr/>
-        </p:nvSpPr>
-        <p:spPr>
-          <a:xfrm>
-            <a:off x="3429000" y="1920240"/>
-            <a:ext cx="2606040" cy="3840480"/>
-          </a:xfrm>
-          <a:prstGeom prst="roundRect">
-            <a:avLst>
-              <a:gd name="adj" fmla="val 3509"/>
-            </a:avLst>
-          </a:prstGeom>
-          <a:solidFill>
-            <a:srgbClr val="FFFFFF"/>
-          </a:solidFill>
-          <a:ln/>
-          <a:effectLst>
-            <a:outerShdw blurRad="76200" dist="25400" dir="5400000" algn="bl" rotWithShape="0">
-              <a:srgbClr val="0B2027">
-                <a:alpha val="10000"/>
-              </a:srgbClr>
-            </a:outerShdw>
-          </a:effectLst>
-        </p:spPr>
-        <p:txBody>
-          <a:bodyPr/>
-          <a:lstStyle/>
-          <a:p>
-            <a:endParaRPr lang="es-AR"/>
-          </a:p>
-        </p:txBody>
-      </p:sp>
-      <p:sp>
-        <p:nvSpPr>
-          <p:cNvPr id="12" name="Shape 9"/>
-          <p:cNvSpPr/>
-          <p:nvPr/>
-        </p:nvSpPr>
-        <p:spPr>
-          <a:xfrm>
-            <a:off x="3657600" y="2194560"/>
-            <a:ext cx="502920" cy="502920"/>
-          </a:xfrm>
-          <a:prstGeom prst="ellipse">
-            <a:avLst/>
-          </a:prstGeom>
-          <a:solidFill>
-            <a:srgbClr val="00A896"/>
-          </a:solidFill>
-          <a:ln/>
-        </p:spPr>
-        <p:txBody>
-          <a:bodyPr/>
-          <a:lstStyle/>
-          <a:p>
-            <a:endParaRPr lang="es-AR"/>
-          </a:p>
-        </p:txBody>
-      </p:sp>
-      <p:sp>
-        <p:nvSpPr>
-          <p:cNvPr id="13" name="Text 10"/>
-          <p:cNvSpPr txBox="1"/>
-          <p:nvPr/>
-        </p:nvSpPr>
-        <p:spPr>
-          <a:xfrm>
-            <a:off x="3657600" y="2194560"/>
-            <a:ext cx="502920" cy="502920"/>
-          </a:xfrm>
-          <a:prstGeom prst="rect">
-            <a:avLst/>
-          </a:prstGeom>
-          <a:noFill/>
-          <a:ln/>
-        </p:spPr>
-        <p:txBody>
-          <a:bodyPr wrap="square" lIns="0" tIns="0" rIns="0" bIns="0" rtlCol="0" anchor="ctr"/>
-          <a:lstStyle/>
-          <a:p>
-            <a:pPr marL="0" indent="0" algn="ctr">
-              <a:buNone/>
-            </a:pPr>
-            <a:r>
-              <a:rPr lang="en-US" sz="1800" b="1" dirty="0">
-                <a:solidFill>
-                  <a:srgbClr val="FFFFFF"/>
-                </a:solidFill>
-                <a:latin typeface="Cambria" pitchFamily="34" charset="0"/>
-                <a:ea typeface="Cambria" pitchFamily="34" charset="-122"/>
-                <a:cs typeface="Cambria" pitchFamily="34" charset="-120"/>
-              </a:rPr>
-              <a:t>2</a:t>
-            </a:r>
-            <a:endParaRPr lang="en-US" sz="1800" dirty="0"/>
-          </a:p>
-        </p:txBody>
-      </p:sp>
-      <p:sp>
-        <p:nvSpPr>
-          <p:cNvPr id="14" name="Text 11"/>
-          <p:cNvSpPr txBox="1"/>
-          <p:nvPr/>
-        </p:nvSpPr>
-        <p:spPr>
-          <a:xfrm>
-            <a:off x="3630168" y="2880360"/>
-            <a:ext cx="2203704" cy="777240"/>
-          </a:xfrm>
-          <a:prstGeom prst="rect">
-            <a:avLst/>
-          </a:prstGeom>
-          <a:noFill/>
-          <a:ln/>
-        </p:spPr>
-        <p:txBody>
-          <a:bodyPr wrap="square" lIns="0" tIns="0" rIns="0" bIns="0" rtlCol="0" anchor="t"/>
-          <a:lstStyle/>
-          <a:p>
-            <a:pPr marL="0" indent="0">
-              <a:buNone/>
-            </a:pPr>
-            <a:r>
-              <a:rPr lang="en-US" sz="1350" b="1" dirty="0">
-                <a:solidFill>
-                  <a:srgbClr val="0B2027"/>
-                </a:solidFill>
-                <a:latin typeface="Cambria" pitchFamily="34" charset="0"/>
-                <a:ea typeface="Cambria" pitchFamily="34" charset="-122"/>
-                <a:cs typeface="Cambria" pitchFamily="34" charset="-120"/>
-              </a:rPr>
-              <a:t>Módulo del médico</a:t>
-            </a:r>
-            <a:endParaRPr lang="en-US" sz="1350" dirty="0"/>
-          </a:p>
-        </p:txBody>
-      </p:sp>
-      <p:sp>
-        <p:nvSpPr>
-          <p:cNvPr id="15" name="Text 12"/>
-          <p:cNvSpPr txBox="1"/>
-          <p:nvPr/>
-        </p:nvSpPr>
-        <p:spPr>
-          <a:xfrm>
-            <a:off x="3630168" y="3703320"/>
-            <a:ext cx="2203704" cy="1920240"/>
-          </a:xfrm>
-          <a:prstGeom prst="rect">
-            <a:avLst/>
-          </a:prstGeom>
-          <a:noFill/>
-          <a:ln/>
-        </p:spPr>
-        <p:txBody>
-          <a:bodyPr wrap="square" lIns="0" tIns="0" rIns="0" bIns="0" rtlCol="0" anchor="t"/>
-          <a:lstStyle/>
-          <a:p>
-            <a:pPr marL="0" indent="0">
-              <a:lnSpc>
-                <a:spcPct val="120000"/>
-              </a:lnSpc>
-              <a:buNone/>
-            </a:pPr>
-            <a:r>
-              <a:rPr lang="en-US" sz="1100" dirty="0">
-                <a:solidFill>
-                  <a:srgbClr val="4C6B70"/>
-                </a:solidFill>
-                <a:latin typeface="Calibri" pitchFamily="34" charset="0"/>
-                <a:ea typeface="Calibri" pitchFamily="34" charset="-122"/>
-                <a:cs typeface="Calibri" pitchFamily="34" charset="-120"/>
-              </a:rPr>
-              <a:t>Agenda propia, marcado de atendido, observaciones e historial.</a:t>
-            </a:r>
-            <a:endParaRPr lang="en-US" sz="1100" dirty="0"/>
-          </a:p>
-        </p:txBody>
-      </p:sp>
-      <p:sp>
-        <p:nvSpPr>
-          <p:cNvPr id="16" name="Shape 13"/>
-          <p:cNvSpPr/>
-          <p:nvPr/>
-        </p:nvSpPr>
-        <p:spPr>
-          <a:xfrm>
-            <a:off x="6062472" y="3749040"/>
-            <a:ext cx="109728" cy="109728"/>
-          </a:xfrm>
-          <a:prstGeom prst="ellipse">
-            <a:avLst/>
-          </a:prstGeom>
-          <a:solidFill>
-            <a:srgbClr val="028090"/>
-          </a:solidFill>
-          <a:ln/>
-        </p:spPr>
-        <p:txBody>
-          <a:bodyPr/>
-          <a:lstStyle/>
-          <a:p>
-            <a:endParaRPr lang="es-AR"/>
-          </a:p>
-        </p:txBody>
-      </p:sp>
-      <p:sp>
-        <p:nvSpPr>
-          <p:cNvPr id="17" name="Shape 14"/>
-          <p:cNvSpPr/>
-          <p:nvPr/>
-        </p:nvSpPr>
-        <p:spPr>
-          <a:xfrm>
-            <a:off x="6217920" y="1920240"/>
-            <a:ext cx="2606040" cy="3840480"/>
-          </a:xfrm>
-          <a:prstGeom prst="roundRect">
-            <a:avLst>
-              <a:gd name="adj" fmla="val 3509"/>
-            </a:avLst>
-          </a:prstGeom>
-          <a:solidFill>
-            <a:srgbClr val="FFFFFF"/>
-          </a:solidFill>
-          <a:ln/>
-          <a:effectLst>
-            <a:outerShdw blurRad="76200" dist="25400" dir="5400000" algn="bl" rotWithShape="0">
-              <a:srgbClr val="0B2027">
-                <a:alpha val="10000"/>
-              </a:srgbClr>
-            </a:outerShdw>
-          </a:effectLst>
-        </p:spPr>
-        <p:txBody>
-          <a:bodyPr/>
-          <a:lstStyle/>
-          <a:p>
-            <a:endParaRPr lang="es-AR"/>
-          </a:p>
-        </p:txBody>
-      </p:sp>
-      <p:sp>
-        <p:nvSpPr>
-          <p:cNvPr id="18" name="Shape 15"/>
-          <p:cNvSpPr/>
-          <p:nvPr/>
-        </p:nvSpPr>
-        <p:spPr>
-          <a:xfrm>
-            <a:off x="6446520" y="2194560"/>
-            <a:ext cx="502920" cy="502920"/>
-          </a:xfrm>
-          <a:prstGeom prst="ellipse">
-            <a:avLst/>
-          </a:prstGeom>
-          <a:solidFill>
-            <a:srgbClr val="00A896"/>
-          </a:solidFill>
-          <a:ln/>
-        </p:spPr>
-        <p:txBody>
-          <a:bodyPr/>
-          <a:lstStyle/>
-          <a:p>
-            <a:endParaRPr lang="es-AR"/>
-          </a:p>
-        </p:txBody>
-      </p:sp>
-      <p:sp>
-        <p:nvSpPr>
-          <p:cNvPr id="19" name="Text 16"/>
-          <p:cNvSpPr txBox="1"/>
-          <p:nvPr/>
-        </p:nvSpPr>
-        <p:spPr>
-          <a:xfrm>
-            <a:off x="6446520" y="2194560"/>
-            <a:ext cx="502920" cy="502920"/>
-          </a:xfrm>
-          <a:prstGeom prst="rect">
-            <a:avLst/>
-          </a:prstGeom>
-          <a:noFill/>
-          <a:ln/>
-        </p:spPr>
-        <p:txBody>
-          <a:bodyPr wrap="square" lIns="0" tIns="0" rIns="0" bIns="0" rtlCol="0" anchor="ctr"/>
-          <a:lstStyle/>
-          <a:p>
-            <a:pPr marL="0" indent="0" algn="ctr">
-              <a:buNone/>
-            </a:pPr>
-            <a:r>
-              <a:rPr lang="en-US" sz="1800" b="1" dirty="0">
-                <a:solidFill>
-                  <a:srgbClr val="FFFFFF"/>
-                </a:solidFill>
-                <a:latin typeface="Cambria" pitchFamily="34" charset="0"/>
-                <a:ea typeface="Cambria" pitchFamily="34" charset="-122"/>
-                <a:cs typeface="Cambria" pitchFamily="34" charset="-120"/>
-              </a:rPr>
-              <a:t>3</a:t>
-            </a:r>
-            <a:endParaRPr lang="en-US" sz="1800" dirty="0"/>
-          </a:p>
-        </p:txBody>
-      </p:sp>
-      <p:sp>
-        <p:nvSpPr>
-          <p:cNvPr id="20" name="Text 17"/>
-          <p:cNvSpPr txBox="1"/>
-          <p:nvPr/>
-        </p:nvSpPr>
-        <p:spPr>
-          <a:xfrm>
-            <a:off x="6419088" y="2880360"/>
-            <a:ext cx="2203704" cy="777240"/>
-          </a:xfrm>
-          <a:prstGeom prst="rect">
-            <a:avLst/>
-          </a:prstGeom>
-          <a:noFill/>
-          <a:ln/>
-        </p:spPr>
-        <p:txBody>
-          <a:bodyPr wrap="square" lIns="0" tIns="0" rIns="0" bIns="0" rtlCol="0" anchor="t"/>
-          <a:lstStyle/>
-          <a:p>
-            <a:pPr marL="0" indent="0">
-              <a:buNone/>
-            </a:pPr>
-            <a:r>
-              <a:rPr lang="en-US" sz="1350" b="1" dirty="0">
-                <a:solidFill>
-                  <a:srgbClr val="0B2027"/>
-                </a:solidFill>
-                <a:latin typeface="Cambria" pitchFamily="34" charset="0"/>
-                <a:ea typeface="Cambria" pitchFamily="34" charset="-122"/>
-                <a:cs typeface="Cambria" pitchFamily="34" charset="-120"/>
-              </a:rPr>
-              <a:t>ABM de usuarios y reportes</a:t>
-            </a:r>
-            <a:endParaRPr lang="en-US" sz="1350" dirty="0"/>
-          </a:p>
-        </p:txBody>
-      </p:sp>
-      <p:sp>
-        <p:nvSpPr>
-          <p:cNvPr id="21" name="Text 18"/>
-          <p:cNvSpPr txBox="1"/>
-          <p:nvPr/>
-        </p:nvSpPr>
-        <p:spPr>
-          <a:xfrm>
-            <a:off x="6419088" y="3703320"/>
-            <a:ext cx="2203704" cy="1920240"/>
-          </a:xfrm>
-          <a:prstGeom prst="rect">
-            <a:avLst/>
-          </a:prstGeom>
-          <a:noFill/>
-          <a:ln/>
-        </p:spPr>
-        <p:txBody>
-          <a:bodyPr wrap="square" lIns="0" tIns="0" rIns="0" bIns="0" rtlCol="0" anchor="t"/>
-          <a:lstStyle/>
-          <a:p>
-            <a:pPr marL="0" indent="0">
-              <a:lnSpc>
-                <a:spcPct val="120000"/>
-              </a:lnSpc>
-              <a:buNone/>
-            </a:pPr>
-            <a:r>
-              <a:rPr lang="en-US" sz="1100" dirty="0">
-                <a:solidFill>
-                  <a:srgbClr val="4C6B70"/>
-                </a:solidFill>
-                <a:latin typeface="Calibri" pitchFamily="34" charset="0"/>
-                <a:ea typeface="Calibri" pitchFamily="34" charset="-122"/>
-                <a:cs typeface="Calibri" pitchFamily="34" charset="-120"/>
-              </a:rPr>
-              <a:t>Alta de usuarios por rol y reportes de gestión para el administrador.</a:t>
-            </a:r>
-            <a:endParaRPr lang="en-US" sz="1100" dirty="0"/>
-          </a:p>
-        </p:txBody>
-      </p:sp>
-      <p:sp>
-        <p:nvSpPr>
-          <p:cNvPr id="22" name="Shape 19"/>
-          <p:cNvSpPr/>
-          <p:nvPr/>
-        </p:nvSpPr>
-        <p:spPr>
-          <a:xfrm>
-            <a:off x="8851392" y="3749040"/>
-            <a:ext cx="109728" cy="109728"/>
-          </a:xfrm>
-          <a:prstGeom prst="ellipse">
-            <a:avLst/>
-          </a:prstGeom>
-          <a:solidFill>
-            <a:srgbClr val="028090"/>
-          </a:solidFill>
-          <a:ln/>
-        </p:spPr>
-        <p:txBody>
-          <a:bodyPr/>
-          <a:lstStyle/>
-          <a:p>
-            <a:endParaRPr lang="es-AR"/>
-          </a:p>
-        </p:txBody>
-      </p:sp>
-      <p:sp>
-        <p:nvSpPr>
-          <p:cNvPr id="23" name="Shape 20"/>
-          <p:cNvSpPr/>
-          <p:nvPr/>
-        </p:nvSpPr>
-        <p:spPr>
-          <a:xfrm>
-            <a:off x="9006840" y="1920240"/>
-            <a:ext cx="2606040" cy="3840480"/>
-          </a:xfrm>
-          <a:prstGeom prst="roundRect">
-            <a:avLst>
-              <a:gd name="adj" fmla="val 3509"/>
-            </a:avLst>
-          </a:prstGeom>
-          <a:solidFill>
-            <a:srgbClr val="FFFFFF"/>
-          </a:solidFill>
-          <a:ln/>
-          <a:effectLst>
-            <a:outerShdw blurRad="76200" dist="25400" dir="5400000" algn="bl" rotWithShape="0">
-              <a:srgbClr val="0B2027">
-                <a:alpha val="10000"/>
-              </a:srgbClr>
-            </a:outerShdw>
-          </a:effectLst>
-        </p:spPr>
-        <p:txBody>
-          <a:bodyPr/>
-          <a:lstStyle/>
-          <a:p>
-            <a:endParaRPr lang="es-AR"/>
-          </a:p>
-        </p:txBody>
-      </p:sp>
-      <p:sp>
-        <p:nvSpPr>
-          <p:cNvPr id="24" name="Shape 21"/>
-          <p:cNvSpPr/>
-          <p:nvPr/>
-        </p:nvSpPr>
-        <p:spPr>
-          <a:xfrm>
-            <a:off x="9235440" y="2194560"/>
-            <a:ext cx="502920" cy="502920"/>
-          </a:xfrm>
-          <a:prstGeom prst="ellipse">
-            <a:avLst/>
-          </a:prstGeom>
-          <a:solidFill>
-            <a:srgbClr val="00A896"/>
-          </a:solidFill>
-          <a:ln/>
-        </p:spPr>
-        <p:txBody>
-          <a:bodyPr/>
-          <a:lstStyle/>
-          <a:p>
-            <a:endParaRPr lang="es-AR"/>
-          </a:p>
-        </p:txBody>
-      </p:sp>
-      <p:sp>
-        <p:nvSpPr>
-          <p:cNvPr id="25" name="Text 22"/>
-          <p:cNvSpPr txBox="1"/>
-          <p:nvPr/>
-        </p:nvSpPr>
-        <p:spPr>
-          <a:xfrm>
-            <a:off x="9235440" y="2194560"/>
-            <a:ext cx="502920" cy="502920"/>
-          </a:xfrm>
-          <a:prstGeom prst="rect">
-            <a:avLst/>
-          </a:prstGeom>
-          <a:noFill/>
-          <a:ln/>
-        </p:spPr>
-        <p:txBody>
-          <a:bodyPr wrap="square" lIns="0" tIns="0" rIns="0" bIns="0" rtlCol="0" anchor="ctr"/>
-          <a:lstStyle/>
-          <a:p>
-            <a:pPr marL="0" indent="0" algn="ctr">
-              <a:buNone/>
-            </a:pPr>
-            <a:r>
-              <a:rPr lang="en-US" sz="1800" b="1" dirty="0">
-                <a:solidFill>
-                  <a:srgbClr val="FFFFFF"/>
-                </a:solidFill>
-                <a:latin typeface="Cambria" pitchFamily="34" charset="0"/>
-                <a:ea typeface="Cambria" pitchFamily="34" charset="-122"/>
-                <a:cs typeface="Cambria" pitchFamily="34" charset="-120"/>
-              </a:rPr>
-              <a:t>4</a:t>
-            </a:r>
-            <a:endParaRPr lang="en-US" sz="1800" dirty="0"/>
-          </a:p>
-        </p:txBody>
-      </p:sp>
-      <p:sp>
-        <p:nvSpPr>
-          <p:cNvPr id="26" name="Text 23"/>
-          <p:cNvSpPr txBox="1"/>
-          <p:nvPr/>
-        </p:nvSpPr>
-        <p:spPr>
-          <a:xfrm>
-            <a:off x="9208008" y="2880360"/>
-            <a:ext cx="2203704" cy="777240"/>
-          </a:xfrm>
-          <a:prstGeom prst="rect">
-            <a:avLst/>
-          </a:prstGeom>
-          <a:noFill/>
-          <a:ln/>
-        </p:spPr>
-        <p:txBody>
-          <a:bodyPr wrap="square" lIns="0" tIns="0" rIns="0" bIns="0" rtlCol="0" anchor="t"/>
-          <a:lstStyle/>
-          <a:p>
-            <a:pPr marL="0" indent="0">
-              <a:buNone/>
-            </a:pPr>
-            <a:r>
-              <a:rPr lang="en-US" sz="1350" b="1" dirty="0">
-                <a:solidFill>
-                  <a:srgbClr val="0B2027"/>
-                </a:solidFill>
-                <a:latin typeface="Cambria" pitchFamily="34" charset="0"/>
-                <a:ea typeface="Cambria" pitchFamily="34" charset="-122"/>
-                <a:cs typeface="Cambria" pitchFamily="34" charset="-120"/>
-              </a:rPr>
-              <a:t>Persistencia en JSON</a:t>
-            </a:r>
-            <a:endParaRPr lang="en-US" sz="1350" dirty="0"/>
-          </a:p>
-        </p:txBody>
-      </p:sp>
-      <p:sp>
-        <p:nvSpPr>
-          <p:cNvPr id="27" name="Text 24"/>
-          <p:cNvSpPr txBox="1"/>
-          <p:nvPr/>
-        </p:nvSpPr>
-        <p:spPr>
-          <a:xfrm>
-            <a:off x="9208008" y="3703320"/>
-            <a:ext cx="2203704" cy="1920240"/>
-          </a:xfrm>
-          <a:prstGeom prst="rect">
-            <a:avLst/>
-          </a:prstGeom>
-          <a:noFill/>
-          <a:ln/>
-        </p:spPr>
-        <p:txBody>
-          <a:bodyPr wrap="square" lIns="0" tIns="0" rIns="0" bIns="0" rtlCol="0" anchor="t"/>
-          <a:lstStyle/>
-          <a:p>
-            <a:pPr marL="0" indent="0">
-              <a:lnSpc>
-                <a:spcPct val="120000"/>
-              </a:lnSpc>
-              <a:buNone/>
-            </a:pPr>
-            <a:r>
-              <a:rPr lang="en-US" sz="1100" dirty="0">
-                <a:solidFill>
-                  <a:srgbClr val="4C6B70"/>
-                </a:solidFill>
-                <a:latin typeface="Calibri" pitchFamily="34" charset="0"/>
-                <a:ea typeface="Calibri" pitchFamily="34" charset="-122"/>
-                <a:cs typeface="Calibri" pitchFamily="34" charset="-120"/>
-              </a:rPr>
-              <a:t>Los datos se guardan y se recuperan entre ejecuciones.</a:t>
-            </a:r>
-            <a:endParaRPr lang="en-US" sz="1100" dirty="0"/>
-          </a:p>
-        </p:txBody>
-      </p:sp>
-      <p:sp>
-        <p:nvSpPr>
-          <p:cNvPr id="28" name="Text 25"/>
-          <p:cNvSpPr txBox="1"/>
-          <p:nvPr/>
-        </p:nvSpPr>
-        <p:spPr>
-          <a:xfrm>
-            <a:off x="457200" y="6473952"/>
-            <a:ext cx="7315200" cy="274320"/>
-          </a:xfrm>
-          <a:prstGeom prst="rect">
-            <a:avLst/>
-          </a:prstGeom>
-          <a:noFill/>
-          <a:ln/>
-        </p:spPr>
-        <p:txBody>
-          <a:bodyPr wrap="square" lIns="0" tIns="0" rIns="0" bIns="0" rtlCol="0" anchor="ctr"/>
-          <a:lstStyle/>
-          <a:p>
-            <a:pPr marL="0" indent="0">
-              <a:buNone/>
-            </a:pPr>
-            <a:r>
-              <a:rPr lang="en-US" sz="900" dirty="0">
-                <a:solidFill>
-                  <a:srgbClr val="4C6B70"/>
-                </a:solidFill>
-                <a:latin typeface="Calibri" pitchFamily="34" charset="0"/>
-                <a:ea typeface="Calibri" pitchFamily="34" charset="-122"/>
-                <a:cs typeface="Calibri" pitchFamily="34" charset="-120"/>
-              </a:rPr>
-              <a:t>SIGET — Sistema de Gestión de Turnos Médicos</a:t>
-            </a:r>
-            <a:endParaRPr lang="en-US" sz="900" dirty="0"/>
-          </a:p>
-        </p:txBody>
-      </p:sp>
-      <p:sp>
-        <p:nvSpPr>
-          <p:cNvPr id="29" name="Text 26"/>
-          <p:cNvSpPr txBox="1"/>
-          <p:nvPr/>
-        </p:nvSpPr>
-        <p:spPr>
-          <a:xfrm>
-            <a:off x="11274552" y="6473952"/>
-            <a:ext cx="457200" cy="274320"/>
-          </a:xfrm>
-          <a:prstGeom prst="rect">
-            <a:avLst/>
-          </a:prstGeom>
-          <a:noFill/>
-          <a:ln/>
-        </p:spPr>
-        <p:txBody>
-          <a:bodyPr wrap="square" lIns="0" tIns="0" rIns="0" bIns="0" rtlCol="0" anchor="ctr"/>
-          <a:lstStyle/>
-          <a:p>
-            <a:pPr marL="0" indent="0" algn="r">
-              <a:buNone/>
-            </a:pPr>
-            <a:r>
-              <a:rPr lang="en-US" sz="900" dirty="0">
-                <a:solidFill>
-                  <a:srgbClr val="4C6B70"/>
-                </a:solidFill>
-                <a:latin typeface="Calibri" pitchFamily="34" charset="0"/>
-                <a:ea typeface="Calibri" pitchFamily="34" charset="-122"/>
-                <a:cs typeface="Calibri" pitchFamily="34" charset="-120"/>
-              </a:rPr>
-              <a:t>9</a:t>
             </a:r>
             <a:endParaRPr lang="en-US" sz="900" dirty="0"/>
           </a:p>

</xml_diff>

<commit_message>
retoques en al presentacion
</commit_message>
<xml_diff>
--- a/SIGET_Presentacion_40%.pptx
+++ b/SIGET_Presentacion_40%.pptx
@@ -2761,13 +2761,13 @@
       </p:sp>
       <p:sp>
         <p:nvSpPr>
-          <p:cNvPr id="3" name="Shape 1"/>
+          <p:cNvPr id="7" name="Shape 4"/>
           <p:cNvSpPr/>
           <p:nvPr/>
         </p:nvSpPr>
         <p:spPr>
           <a:xfrm>
-            <a:off x="617220" y="1485900"/>
+            <a:off x="1833924" y="1954845"/>
             <a:ext cx="960120" cy="960120"/>
           </a:xfrm>
           <a:prstGeom prst="ellipse">
@@ -2788,7 +2788,7 @@
       </p:sp>
       <p:pic>
         <p:nvPicPr>
-          <p:cNvPr id="4" name="Image 0" descr="icons/signIn.png"/>
+          <p:cNvPr id="8" name="Image 1" descr="icons/usersCog.png"/>
           <p:cNvPicPr>
             <a:picLocks noChangeAspect="1"/>
           </p:cNvPicPr>
@@ -2802,7 +2802,7 @@
         </p:blipFill>
         <p:spPr>
           <a:xfrm>
-            <a:off x="854964" y="1723644"/>
+            <a:off x="2083098" y="2151126"/>
             <a:ext cx="484632" cy="484632"/>
           </a:xfrm>
           <a:prstGeom prst="rect">
@@ -2812,13 +2812,13 @@
       </p:pic>
       <p:sp>
         <p:nvSpPr>
-          <p:cNvPr id="5" name="Text 2"/>
+          <p:cNvPr id="9" name="Text 5"/>
           <p:cNvSpPr txBox="1"/>
           <p:nvPr/>
         </p:nvSpPr>
         <p:spPr>
           <a:xfrm>
-            <a:off x="1737360" y="1536192"/>
+            <a:off x="2965494" y="1963674"/>
             <a:ext cx="2240280" cy="457200"/>
           </a:xfrm>
           <a:prstGeom prst="rect">
@@ -2843,7 +2843,7 @@
                 <a:ea typeface="Cambria" pitchFamily="34" charset="-122"/>
                 <a:cs typeface="Cambria" pitchFamily="34" charset="-120"/>
               </a:rPr>
-              <a:t>Inicio de sesión por rol</a:t>
+              <a:t>ABM de las entidades</a:t>
             </a:r>
             <a:endParaRPr lang="en-US" sz="1400" dirty="0"/>
           </a:p>
@@ -2851,13 +2851,13 @@
       </p:sp>
       <p:sp>
         <p:nvSpPr>
-          <p:cNvPr id="6" name="Text 3"/>
+          <p:cNvPr id="10" name="Text 6"/>
           <p:cNvSpPr txBox="1"/>
           <p:nvPr/>
         </p:nvSpPr>
         <p:spPr>
           <a:xfrm>
-            <a:off x="1737360" y="1993392"/>
+            <a:off x="2965494" y="2420874"/>
             <a:ext cx="2240280" cy="1005840"/>
           </a:xfrm>
           <a:prstGeom prst="rect">
@@ -2885,7 +2885,7 @@
                 <a:ea typeface="Calibri" pitchFamily="34" charset="-122"/>
                 <a:cs typeface="Calibri" pitchFamily="34" charset="-120"/>
               </a:rPr>
-              <a:t>Un menú distinto según lo que cada rol tiene permitido hacer.</a:t>
+              <a:t>Usuarios, médicos, especialidades, obras sociales y pacientes.</a:t>
             </a:r>
             <a:endParaRPr lang="en-US" sz="1150" dirty="0"/>
           </a:p>
@@ -2893,13 +2893,13 @@
       </p:sp>
       <p:sp>
         <p:nvSpPr>
-          <p:cNvPr id="7" name="Shape 4"/>
+          <p:cNvPr id="11" name="Shape 7"/>
           <p:cNvSpPr/>
           <p:nvPr/>
         </p:nvSpPr>
         <p:spPr>
           <a:xfrm>
-            <a:off x="4320540" y="1485900"/>
+            <a:off x="5548674" y="1913382"/>
             <a:ext cx="960120" cy="960120"/>
           </a:xfrm>
           <a:prstGeom prst="ellipse">
@@ -2920,7 +2920,7 @@
       </p:sp>
       <p:pic>
         <p:nvPicPr>
-          <p:cNvPr id="8" name="Image 1" descr="icons/usersCog.png"/>
+          <p:cNvPr id="12" name="Image 2" descr="icons/calendarCheck.png"/>
           <p:cNvPicPr>
             <a:picLocks noChangeAspect="1"/>
           </p:cNvPicPr>
@@ -2934,7 +2934,7 @@
         </p:blipFill>
         <p:spPr>
           <a:xfrm>
-            <a:off x="4558284" y="1723644"/>
+            <a:off x="5786418" y="2151126"/>
             <a:ext cx="484632" cy="484632"/>
           </a:xfrm>
           <a:prstGeom prst="rect">
@@ -2944,13 +2944,13 @@
       </p:pic>
       <p:sp>
         <p:nvSpPr>
-          <p:cNvPr id="9" name="Text 5"/>
+          <p:cNvPr id="13" name="Text 8"/>
           <p:cNvSpPr txBox="1"/>
           <p:nvPr/>
         </p:nvSpPr>
         <p:spPr>
           <a:xfrm>
-            <a:off x="5440680" y="1536192"/>
+            <a:off x="6668814" y="1963674"/>
             <a:ext cx="2240280" cy="457200"/>
           </a:xfrm>
           <a:prstGeom prst="rect">
@@ -2975,7 +2975,7 @@
                 <a:ea typeface="Cambria" pitchFamily="34" charset="-122"/>
                 <a:cs typeface="Cambria" pitchFamily="34" charset="-120"/>
               </a:rPr>
-              <a:t>ABM de las entidades</a:t>
+              <a:t>Turnos sin superposición</a:t>
             </a:r>
             <a:endParaRPr lang="en-US" sz="1400" dirty="0"/>
           </a:p>
@@ -2983,13 +2983,13 @@
       </p:sp>
       <p:sp>
         <p:nvSpPr>
-          <p:cNvPr id="10" name="Text 6"/>
+          <p:cNvPr id="14" name="Text 9"/>
           <p:cNvSpPr txBox="1"/>
           <p:nvPr/>
         </p:nvSpPr>
         <p:spPr>
           <a:xfrm>
-            <a:off x="5440680" y="1993392"/>
+            <a:off x="6668814" y="2420874"/>
             <a:ext cx="2240280" cy="1005840"/>
           </a:xfrm>
           <a:prstGeom prst="rect">
@@ -3017,7 +3017,7 @@
                 <a:ea typeface="Calibri" pitchFamily="34" charset="-122"/>
                 <a:cs typeface="Calibri" pitchFamily="34" charset="-120"/>
               </a:rPr>
-              <a:t>Usuarios, médicos, especialidades, obras sociales y pacientes.</a:t>
+              <a:t>Que no se asignen fuera del horario de atención del médico.</a:t>
             </a:r>
             <a:endParaRPr lang="en-US" sz="1150" dirty="0"/>
           </a:p>
@@ -3025,13 +3025,13 @@
       </p:sp>
       <p:sp>
         <p:nvSpPr>
-          <p:cNvPr id="11" name="Shape 7"/>
+          <p:cNvPr id="15" name="Shape 10"/>
           <p:cNvSpPr/>
           <p:nvPr/>
         </p:nvSpPr>
         <p:spPr>
           <a:xfrm>
-            <a:off x="8023860" y="1485900"/>
+            <a:off x="1845354" y="4043067"/>
             <a:ext cx="960120" cy="960120"/>
           </a:xfrm>
           <a:prstGeom prst="ellipse">
@@ -3052,7 +3052,7 @@
       </p:sp>
       <p:pic>
         <p:nvPicPr>
-          <p:cNvPr id="12" name="Image 2" descr="icons/calendarCheck.png"/>
+          <p:cNvPr id="16" name="Image 3" descr="icons/clipboard.png"/>
           <p:cNvPicPr>
             <a:picLocks noChangeAspect="1"/>
           </p:cNvPicPr>
@@ -3066,7 +3066,7 @@
         </p:blipFill>
         <p:spPr>
           <a:xfrm>
-            <a:off x="8261604" y="1723644"/>
+            <a:off x="2083098" y="4280811"/>
             <a:ext cx="484632" cy="484632"/>
           </a:xfrm>
           <a:prstGeom prst="rect">
@@ -3076,13 +3076,13 @@
       </p:pic>
       <p:sp>
         <p:nvSpPr>
-          <p:cNvPr id="13" name="Text 8"/>
+          <p:cNvPr id="17" name="Text 11"/>
           <p:cNvSpPr txBox="1"/>
           <p:nvPr/>
         </p:nvSpPr>
         <p:spPr>
           <a:xfrm>
-            <a:off x="9144000" y="1536192"/>
+            <a:off x="2965494" y="4093359"/>
             <a:ext cx="2240280" cy="457200"/>
           </a:xfrm>
           <a:prstGeom prst="rect">
@@ -3107,7 +3107,7 @@
                 <a:ea typeface="Cambria" pitchFamily="34" charset="-122"/>
                 <a:cs typeface="Cambria" pitchFamily="34" charset="-120"/>
               </a:rPr>
-              <a:t>Turnos sin superposición</a:t>
+              <a:t>Seguimiento del turno</a:t>
             </a:r>
             <a:endParaRPr lang="en-US" sz="1400" dirty="0"/>
           </a:p>
@@ -3115,13 +3115,13 @@
       </p:sp>
       <p:sp>
         <p:nvSpPr>
-          <p:cNvPr id="14" name="Text 9"/>
+          <p:cNvPr id="18" name="Text 12"/>
           <p:cNvSpPr txBox="1"/>
           <p:nvPr/>
         </p:nvSpPr>
         <p:spPr>
           <a:xfrm>
-            <a:off x="9144000" y="1993392"/>
+            <a:off x="2965494" y="4550559"/>
             <a:ext cx="2240280" cy="1005840"/>
           </a:xfrm>
           <a:prstGeom prst="rect">
@@ -3149,7 +3149,7 @@
                 <a:ea typeface="Calibri" pitchFamily="34" charset="-122"/>
                 <a:cs typeface="Calibri" pitchFamily="34" charset="-120"/>
               </a:rPr>
-              <a:t>Que no se asignen fuera del horario de atención del médico.</a:t>
+              <a:t>Estados (pendiente, atendido, cancelado, ausente) y observaciones.</a:t>
             </a:r>
             <a:endParaRPr lang="en-US" sz="1150" dirty="0"/>
           </a:p>
@@ -3157,13 +3157,13 @@
       </p:sp>
       <p:sp>
         <p:nvSpPr>
-          <p:cNvPr id="15" name="Shape 10"/>
+          <p:cNvPr id="19" name="Shape 13"/>
           <p:cNvSpPr/>
           <p:nvPr/>
         </p:nvSpPr>
         <p:spPr>
           <a:xfrm>
-            <a:off x="617220" y="3909060"/>
+            <a:off x="5548674" y="4043067"/>
             <a:ext cx="960120" cy="960120"/>
           </a:xfrm>
           <a:prstGeom prst="ellipse">
@@ -3184,7 +3184,7 @@
       </p:sp>
       <p:pic>
         <p:nvPicPr>
-          <p:cNvPr id="16" name="Image 3" descr="icons/clipboard.png"/>
+          <p:cNvPr id="20" name="Image 4" descr="icons/search.png"/>
           <p:cNvPicPr>
             <a:picLocks noChangeAspect="1"/>
           </p:cNvPicPr>
@@ -3198,7 +3198,7 @@
         </p:blipFill>
         <p:spPr>
           <a:xfrm>
-            <a:off x="854964" y="4146804"/>
+            <a:off x="5786418" y="4280811"/>
             <a:ext cx="484632" cy="484632"/>
           </a:xfrm>
           <a:prstGeom prst="rect">
@@ -3208,13 +3208,13 @@
       </p:pic>
       <p:sp>
         <p:nvSpPr>
-          <p:cNvPr id="17" name="Text 11"/>
+          <p:cNvPr id="21" name="Text 14"/>
           <p:cNvSpPr txBox="1"/>
           <p:nvPr/>
         </p:nvSpPr>
         <p:spPr>
           <a:xfrm>
-            <a:off x="1737360" y="3959352"/>
+            <a:off x="6668814" y="4093359"/>
             <a:ext cx="2240280" cy="457200"/>
           </a:xfrm>
           <a:prstGeom prst="rect">
@@ -3239,138 +3239,6 @@
                 <a:ea typeface="Cambria" pitchFamily="34" charset="-122"/>
                 <a:cs typeface="Cambria" pitchFamily="34" charset="-120"/>
               </a:rPr>
-              <a:t>Seguimiento del turno</a:t>
-            </a:r>
-            <a:endParaRPr lang="en-US" sz="1400" dirty="0"/>
-          </a:p>
-        </p:txBody>
-      </p:sp>
-      <p:sp>
-        <p:nvSpPr>
-          <p:cNvPr id="18" name="Text 12"/>
-          <p:cNvSpPr txBox="1"/>
-          <p:nvPr/>
-        </p:nvSpPr>
-        <p:spPr>
-          <a:xfrm>
-            <a:off x="1737360" y="4416552"/>
-            <a:ext cx="2240280" cy="1005840"/>
-          </a:xfrm>
-          <a:prstGeom prst="rect">
-            <a:avLst/>
-          </a:prstGeom>
-          <a:noFill/>
-          <a:ln/>
-        </p:spPr>
-        <p:txBody>
-          <a:bodyPr wrap="square" lIns="0" tIns="0" rIns="0" bIns="0" rtlCol="0" anchor="t"/>
-          <a:lstStyle/>
-          <a:p>
-            <a:pPr marL="0" indent="0">
-              <a:lnSpc>
-                <a:spcPct val="115000"/>
-              </a:lnSpc>
-              <a:buNone/>
-            </a:pPr>
-            <a:r>
-              <a:rPr lang="en-US" sz="1150" dirty="0">
-                <a:solidFill>
-                  <a:srgbClr val="4C6B70"/>
-                </a:solidFill>
-                <a:latin typeface="Calibri" pitchFamily="34" charset="0"/>
-                <a:ea typeface="Calibri" pitchFamily="34" charset="-122"/>
-                <a:cs typeface="Calibri" pitchFamily="34" charset="-120"/>
-              </a:rPr>
-              <a:t>Estados (pendiente, atendido, cancelado, ausente) y observaciones.</a:t>
-            </a:r>
-            <a:endParaRPr lang="en-US" sz="1150" dirty="0"/>
-          </a:p>
-        </p:txBody>
-      </p:sp>
-      <p:sp>
-        <p:nvSpPr>
-          <p:cNvPr id="19" name="Shape 13"/>
-          <p:cNvSpPr/>
-          <p:nvPr/>
-        </p:nvSpPr>
-        <p:spPr>
-          <a:xfrm>
-            <a:off x="4320540" y="3909060"/>
-            <a:ext cx="960120" cy="960120"/>
-          </a:xfrm>
-          <a:prstGeom prst="ellipse">
-            <a:avLst/>
-          </a:prstGeom>
-          <a:solidFill>
-            <a:srgbClr val="00A896"/>
-          </a:solidFill>
-          <a:ln/>
-        </p:spPr>
-        <p:txBody>
-          <a:bodyPr/>
-          <a:lstStyle/>
-          <a:p>
-            <a:endParaRPr lang="es-AR"/>
-          </a:p>
-        </p:txBody>
-      </p:sp>
-      <p:pic>
-        <p:nvPicPr>
-          <p:cNvPr id="20" name="Image 4" descr="icons/search.png"/>
-          <p:cNvPicPr>
-            <a:picLocks noChangeAspect="1"/>
-          </p:cNvPicPr>
-          <p:nvPr/>
-        </p:nvPicPr>
-        <p:blipFill>
-          <a:blip r:embed="rId7"/>
-          <a:stretch>
-            <a:fillRect/>
-          </a:stretch>
-        </p:blipFill>
-        <p:spPr>
-          <a:xfrm>
-            <a:off x="4558284" y="4146804"/>
-            <a:ext cx="484632" cy="484632"/>
-          </a:xfrm>
-          <a:prstGeom prst="rect">
-            <a:avLst/>
-          </a:prstGeom>
-        </p:spPr>
-      </p:pic>
-      <p:sp>
-        <p:nvSpPr>
-          <p:cNvPr id="21" name="Text 14"/>
-          <p:cNvSpPr txBox="1"/>
-          <p:nvPr/>
-        </p:nvSpPr>
-        <p:spPr>
-          <a:xfrm>
-            <a:off x="5440680" y="3959352"/>
-            <a:ext cx="2240280" cy="457200"/>
-          </a:xfrm>
-          <a:prstGeom prst="rect">
-            <a:avLst/>
-          </a:prstGeom>
-          <a:noFill/>
-          <a:ln/>
-        </p:spPr>
-        <p:txBody>
-          <a:bodyPr wrap="square" lIns="0" tIns="0" rIns="0" bIns="0" rtlCol="0" anchor="b"/>
-          <a:lstStyle/>
-          <a:p>
-            <a:pPr marL="0" indent="0">
-              <a:buNone/>
-            </a:pPr>
-            <a:r>
-              <a:rPr lang="en-US" sz="1400" b="1" dirty="0">
-                <a:solidFill>
-                  <a:srgbClr val="0B2027"/>
-                </a:solidFill>
-                <a:latin typeface="Cambria" pitchFamily="34" charset="0"/>
-                <a:ea typeface="Cambria" pitchFamily="34" charset="-122"/>
-                <a:cs typeface="Cambria" pitchFamily="34" charset="-120"/>
-              </a:rPr>
               <a:t>Reportes simples</a:t>
             </a:r>
             <a:endParaRPr lang="en-US" sz="1400" dirty="0"/>
@@ -3385,7 +3253,7 @@
         </p:nvSpPr>
         <p:spPr>
           <a:xfrm>
-            <a:off x="5440680" y="4416552"/>
+            <a:off x="6668814" y="4550559"/>
             <a:ext cx="2240280" cy="1005840"/>
           </a:xfrm>
           <a:prstGeom prst="rect">

</xml_diff>